<commit_message>
docs: recalibrate board pitch to data-signal framing; WCO/LCO aliases
</commit_message>
<xml_diff>
--- a/Board pitch/Owned_Brands_Board_Deck.pptx
+++ b/Board pitch/Owned_Brands_Board_Deck.pptx
@@ -1531,7 +1531,7 @@
                 <a:ea typeface="Consolas" pitchFamily="34" charset="-122"/>
                 <a:cs typeface="Consolas" pitchFamily="34" charset="-120"/>
               </a:rPr>
-              <a:t>OBCO  ·  OWNED BRANDS  ·  BOARD DECISION BRIEF</a:t>
+              <a:t>WCO  ·  OWNED BRANDS  ·  DATAVERS BRIEF</a:t>
             </a:r>
             <a:endParaRPr lang="en-US" sz="1300" dirty="0"/>
           </a:p>
@@ -1573,7 +1573,7 @@
                 <a:ea typeface="Trebuchet MS" pitchFamily="34" charset="-122"/>
                 <a:cs typeface="Trebuchet MS" pitchFamily="34" charset="-120"/>
               </a:rPr>
-              <a:t>Turn competitor sell-through into</a:t>
+              <a:t>The signals to help WCO sellers win deals</a:t>
             </a:r>
             <a:endParaRPr lang="en-US" sz="4000" dirty="0"/>
           </a:p>
@@ -1593,7 +1593,7 @@
                 <a:ea typeface="Trebuchet MS" pitchFamily="34" charset="-122"/>
                 <a:cs typeface="Trebuchet MS" pitchFamily="34" charset="-120"/>
               </a:rPr>
-              <a:t>higher-margin owned-brand revenue.</a:t>
+              <a:t>and hold owned-brand margin.</a:t>
             </a:r>
             <a:endParaRPr lang="en-US" sz="4000" dirty="0"/>
           </a:p>
@@ -1607,8 +1607,8 @@
         </p:nvSpPr>
         <p:spPr>
           <a:xfrm>
-            <a:off x="548640" y="3977640"/>
-            <a:ext cx="9692640" cy="822960"/>
+            <a:off x="548640" y="3931920"/>
+            <a:ext cx="10058400" cy="914400"/>
           </a:xfrm>
           <a:prstGeom prst="rect">
             <a:avLst/>
@@ -1632,7 +1632,7 @@
                 <a:ea typeface="Calibri" pitchFamily="34" charset="-122"/>
                 <a:cs typeface="Calibri" pitchFamily="34" charset="-120"/>
               </a:rPr>
-              <a:t>A vendor-side sales-intelligence and CRM platform inside OBCO — read-only from governed OBCO data, owning only Owned Brands activity.</a:t>
+              <a:t>A read-only, vendor-side intelligence and activity platform inside WCO — it surfaces the signals and tracks our engagement, so the Owned Brands team shows up at the right time with the right pitch.</a:t>
             </a:r>
             <a:endParaRPr lang="en-US" sz="1700" dirty="0"/>
           </a:p>
@@ -1690,7 +1690,7 @@
               <a:buNone/>
             </a:pPr>
             <a:r>
-              <a:rPr lang="en-US" sz="1500" dirty="0">
+              <a:rPr lang="en-US" sz="1300" dirty="0">
                 <a:solidFill>
                   <a:srgbClr val="FFFFFF"/>
                 </a:solidFill>
@@ -1698,13 +1698,13 @@
                 <a:ea typeface="Consolas" pitchFamily="34" charset="-122"/>
                 <a:cs typeface="Consolas" pitchFamily="34" charset="-120"/>
               </a:rPr>
-              <a:t>identify sell-through</a:t>
+              <a:t>surface signal</a:t>
             </a:r>
             <a:pPr algn="ctr" indent="0" marL="0">
               <a:buNone/>
             </a:pPr>
             <a:r>
-              <a:rPr lang="en-US" sz="1500" b="1" dirty="0">
+              <a:rPr lang="en-US" sz="1300" b="1" dirty="0">
                 <a:solidFill>
                   <a:srgbClr val="37B26B"/>
                 </a:solidFill>
@@ -1718,7 +1718,7 @@
               <a:buNone/>
             </a:pPr>
             <a:r>
-              <a:rPr lang="en-US" sz="1500" dirty="0">
+              <a:rPr lang="en-US" sz="1300" dirty="0">
                 <a:solidFill>
                   <a:srgbClr val="FFFFFF"/>
                 </a:solidFill>
@@ -1726,13 +1726,13 @@
                 <a:ea typeface="Consolas" pitchFamily="34" charset="-122"/>
                 <a:cs typeface="Consolas" pitchFamily="34" charset="-120"/>
               </a:rPr>
-              <a:t>cross to owned brand</a:t>
+              <a:t>reach the right seller</a:t>
             </a:r>
             <a:pPr algn="ctr" indent="0" marL="0">
               <a:buNone/>
             </a:pPr>
             <a:r>
-              <a:rPr lang="en-US" sz="1500" b="1" dirty="0">
+              <a:rPr lang="en-US" sz="1300" b="1" dirty="0">
                 <a:solidFill>
                   <a:srgbClr val="37B26B"/>
                 </a:solidFill>
@@ -1746,7 +1746,7 @@
               <a:buNone/>
             </a:pPr>
             <a:r>
-              <a:rPr lang="en-US" sz="1500" dirty="0">
+              <a:rPr lang="en-US" sz="1300" dirty="0">
                 <a:solidFill>
                   <a:srgbClr val="FFFFFF"/>
                 </a:solidFill>
@@ -1754,13 +1754,13 @@
                 <a:ea typeface="Consolas" pitchFamily="34" charset="-122"/>
                 <a:cs typeface="Consolas" pitchFamily="34" charset="-120"/>
               </a:rPr>
-              <a:t>quantify margin lift</a:t>
+              <a:t>win &amp; hold margin</a:t>
             </a:r>
             <a:pPr algn="ctr" indent="0" marL="0">
               <a:buNone/>
             </a:pPr>
             <a:r>
-              <a:rPr lang="en-US" sz="1500" b="1" dirty="0">
+              <a:rPr lang="en-US" sz="1300" b="1" dirty="0">
                 <a:solidFill>
                   <a:srgbClr val="37B26B"/>
                 </a:solidFill>
@@ -1774,7 +1774,7 @@
               <a:buNone/>
             </a:pPr>
             <a:r>
-              <a:rPr lang="en-US" sz="1500" dirty="0">
+              <a:rPr lang="en-US" sz="1300" dirty="0">
                 <a:solidFill>
                   <a:srgbClr val="FFFFFF"/>
                 </a:solidFill>
@@ -1782,9 +1782,9 @@
                 <a:ea typeface="Consolas" pitchFamily="34" charset="-122"/>
                 <a:cs typeface="Consolas" pitchFamily="34" charset="-120"/>
               </a:rPr>
-              <a:t>rep converts</a:t>
-            </a:r>
-            <a:endParaRPr lang="en-US" sz="1500" dirty="0"/>
+              <a:t>owned brands grow</a:t>
+            </a:r>
+            <a:endParaRPr lang="en-US" sz="1300" dirty="0"/>
           </a:p>
         </p:txBody>
       </p:sp>
@@ -1821,7 +1821,7 @@
                 <a:ea typeface="Calibri" pitchFamily="34" charset="-122"/>
                 <a:cs typeface="Calibri" pitchFamily="34" charset="-120"/>
               </a:rPr>
-              <a:t>Director, Owned Brands Sales (OB_Vend &amp; OBCO)   ·   June 19, 2026   ·   Status: Discovery / prototype</a:t>
+              <a:t>Jeff Goodman — Director, Sales, Owned Brands   ·   June 19, 2026   ·   Status: Discovery / prototype</a:t>
             </a:r>
             <a:endParaRPr lang="en-US" sz="1100" dirty="0"/>
           </a:p>
@@ -1892,7 +1892,7 @@
                 <a:ea typeface="Consolas" pitchFamily="34" charset="-122"/>
                 <a:cs typeface="Consolas" pitchFamily="34" charset="-120"/>
               </a:rPr>
-              <a:t>THE OPPORTUNITY</a:t>
+              <a:t>WHO WE ARE — AND WHAT’S MISSING</a:t>
             </a:r>
             <a:endParaRPr lang="en-US" sz="1100" dirty="0"/>
           </a:p>
@@ -1934,7 +1934,7 @@
                 <a:ea typeface="Trebuchet MS" pitchFamily="34" charset="-122"/>
                 <a:cs typeface="Trebuchet MS" pitchFamily="34" charset="-120"/>
               </a:rPr>
-              <a:t>Every competitor part our customers buy is owned-brand margin we can’t see</a:t>
+              <a:t>We can’t see the signals that win deals and hold margin</a:t>
             </a:r>
             <a:endParaRPr lang="en-US" sz="2700" dirty="0"/>
           </a:p>
@@ -2020,7 +2020,7 @@
                 <a:ea typeface="Consolas" pitchFamily="34" charset="-122"/>
                 <a:cs typeface="Consolas" pitchFamily="34" charset="-120"/>
               </a:rPr>
-              <a:t>▲</a:t>
+              <a:t>◉</a:t>
             </a:r>
             <a:endParaRPr lang="en-US" sz="1800" dirty="0"/>
           </a:p>
@@ -2059,7 +2059,7 @@
                 <a:ea typeface="Trebuchet MS" pitchFamily="34" charset="-122"/>
                 <a:cs typeface="Trebuchet MS" pitchFamily="34" charset="-120"/>
               </a:rPr>
-              <a:t>Higher margin, same shelf</a:t>
+              <a:t>We’re the vendor team</a:t>
             </a:r>
             <a:endParaRPr lang="en-US" sz="1600" dirty="0"/>
           </a:p>
@@ -2101,7 +2101,7 @@
                 <a:ea typeface="Calibri" pitchFamily="34" charset="-122"/>
                 <a:cs typeface="Calibri" pitchFamily="34" charset="-120"/>
               </a:rPr>
-              <a:t>Owned-brand product carries materially higher margin than the competitor lines our customers buy today.</a:t>
+              <a:t>The Owned Brands team is WCO’s owned-brands vendor team — our job is to call on WCO sellers and select customers and help them win.</a:t>
             </a:r>
             <a:endParaRPr lang="en-US" sz="1400" dirty="0"/>
           </a:p>
@@ -2187,7 +2187,7 @@
                 <a:ea typeface="Consolas" pitchFamily="34" charset="-122"/>
                 <a:cs typeface="Consolas" pitchFamily="34" charset="-120"/>
               </a:rPr>
-              <a:t>◎</a:t>
+              <a:t>⚑</a:t>
             </a:r>
             <a:endParaRPr lang="en-US" sz="1800" dirty="0"/>
           </a:p>
@@ -2226,7 +2226,7 @@
                 <a:ea typeface="Trebuchet MS" pitchFamily="34" charset="-122"/>
                 <a:cs typeface="Trebuchet MS" pitchFamily="34" charset="-120"/>
               </a:rPr>
-              <a:t>Every customer is a target</a:t>
+              <a:t>We fly blind</a:t>
             </a:r>
             <a:endParaRPr lang="en-US" sz="1600" dirty="0"/>
           </a:p>
@@ -2268,7 +2268,7 @@
                 <a:ea typeface="Calibri" pitchFamily="34" charset="-122"/>
                 <a:cs typeface="Calibri" pitchFamily="34" charset="-120"/>
               </a:rPr>
-              <a:t>Any OBCO customer buying competitor product we can cross is a conversion opportunity — not just OB_Vend AV.</a:t>
+              <a:t>We don’t see which sellers are about to lose a winnable deal, or where competitive pressure is eroding owned-brand margin.</a:t>
             </a:r>
             <a:endParaRPr lang="en-US" sz="1400" dirty="0"/>
           </a:p>
@@ -2354,7 +2354,7 @@
                 <a:ea typeface="Consolas" pitchFamily="34" charset="-122"/>
                 <a:cs typeface="Consolas" pitchFamily="34" charset="-120"/>
               </a:rPr>
-              <a:t>∑</a:t>
+              <a:t>▤</a:t>
             </a:r>
             <a:endParaRPr lang="en-US" sz="1800" dirty="0"/>
           </a:p>
@@ -2393,7 +2393,7 @@
                 <a:ea typeface="Trebuchet MS" pitchFamily="34" charset="-122"/>
                 <a:cs typeface="Trebuchet MS" pitchFamily="34" charset="-120"/>
               </a:rPr>
-              <a:t>Sized once we can see it</a:t>
+              <a:t>It lives in spreadsheets</a:t>
             </a:r>
             <a:endParaRPr lang="en-US" sz="1600" dirty="0"/>
           </a:p>
@@ -2435,7 +2435,7 @@
                 <a:ea typeface="Calibri" pitchFamily="34" charset="-122"/>
                 <a:cs typeface="Calibri" pitchFamily="34" charset="-120"/>
               </a:rPr>
-              <a:t>Total addressable lift is quantified with the Data Office the moment sell-through access is granted.</a:t>
+              <a:t>WCO’s distributor systems were never built for the vendor lens, so the work — and the signal — scatters across disconnected files.</a:t>
             </a:r>
             <a:endParaRPr lang="en-US" sz="1400" dirty="0"/>
           </a:p>
@@ -2474,7 +2474,7 @@
                 <a:ea typeface="Calibri" pitchFamily="34" charset="-122"/>
                 <a:cs typeface="Calibri" pitchFamily="34" charset="-120"/>
               </a:rPr>
-              <a:t>The platform’s job: find that sell-through at scale and route it to a rep.</a:t>
+              <a:t>The platform’s job: surface those signals and put us in the right place at the right time.</a:t>
             </a:r>
             <a:endParaRPr lang="en-US" sz="1500" dirty="0"/>
           </a:p>
@@ -3047,7 +3047,7 @@
                 <a:ea typeface="Calibri" pitchFamily="34" charset="-122"/>
                 <a:cs typeface="Calibri" pitchFamily="34" charset="-120"/>
               </a:rPr>
-              <a:t>Today the conversion pipeline lives in disconnected spreadsheets — invisible to leadership and impossible to scale.</a:t>
+              <a:t>Without the vendor lens, the signal lives in disconnected spreadsheets — invisible to leadership and impossible to scale.</a:t>
             </a:r>
             <a:endParaRPr lang="en-US" sz="1500" dirty="0"/>
           </a:p>
@@ -3213,7 +3213,7 @@
                 <a:ea typeface="Trebuchet MS" pitchFamily="34" charset="-122"/>
                 <a:cs typeface="Trebuchet MS" pitchFamily="34" charset="-120"/>
               </a:rPr>
-              <a:t>One loop converts competitor sell-through into margin</a:t>
+              <a:t>One loop puts us in the right deal at the right time</a:t>
             </a:r>
             <a:endParaRPr lang="en-US" sz="2700" dirty="0"/>
           </a:p>
@@ -3338,7 +3338,7 @@
                 <a:ea typeface="Trebuchet MS" pitchFamily="34" charset="-122"/>
                 <a:cs typeface="Trebuchet MS" pitchFamily="34" charset="-120"/>
               </a:rPr>
-              <a:t>Identify</a:t>
+              <a:t>Surface</a:t>
             </a:r>
             <a:endParaRPr lang="en-US" sz="1800" dirty="0"/>
           </a:p>
@@ -3380,7 +3380,7 @@
                 <a:ea typeface="Calibri" pitchFamily="34" charset="-122"/>
                 <a:cs typeface="Calibri" pitchFamily="34" charset="-120"/>
               </a:rPr>
-              <a:t>Competitor sell-through in the governed data</a:t>
+              <a:t>Signal in the governed data — deal at risk or margin under pressure</a:t>
             </a:r>
             <a:endParaRPr lang="en-US" sz="1300" dirty="0"/>
           </a:p>
@@ -3544,7 +3544,7 @@
                 <a:ea typeface="Trebuchet MS" pitchFamily="34" charset="-122"/>
                 <a:cs typeface="Trebuchet MS" pitchFamily="34" charset="-120"/>
               </a:rPr>
-              <a:t>Cross</a:t>
+              <a:t>Reach</a:t>
             </a:r>
             <a:endParaRPr lang="en-US" sz="1800" dirty="0"/>
           </a:p>
@@ -3586,7 +3586,7 @@
                 <a:ea typeface="Calibri" pitchFamily="34" charset="-122"/>
                 <a:cs typeface="Calibri" pitchFamily="34" charset="-120"/>
               </a:rPr>
-              <a:t>Map the part to an owned-brand equivalent</a:t>
+              <a:t>The right WCO seller or customer, with the cross and the context</a:t>
             </a:r>
             <a:endParaRPr lang="en-US" sz="1300" dirty="0"/>
           </a:p>
@@ -3750,7 +3750,7 @@
                 <a:ea typeface="Trebuchet MS" pitchFamily="34" charset="-122"/>
                 <a:cs typeface="Trebuchet MS" pitchFamily="34" charset="-120"/>
               </a:rPr>
-              <a:t>Quantify</a:t>
+              <a:t>Win</a:t>
             </a:r>
             <a:endParaRPr lang="en-US" sz="1800" dirty="0"/>
           </a:p>
@@ -3792,7 +3792,7 @@
                 <a:ea typeface="Calibri" pitchFamily="34" charset="-122"/>
                 <a:cs typeface="Calibri" pitchFamily="34" charset="-120"/>
               </a:rPr>
-              <a:t>Compute the margin lift of the switch</a:t>
+              <a:t>Help close the deal and hold owned-brand margin</a:t>
             </a:r>
             <a:endParaRPr lang="en-US" sz="1300" dirty="0"/>
           </a:p>
@@ -3956,7 +3956,7 @@
                 <a:ea typeface="Trebuchet MS" pitchFamily="34" charset="-122"/>
                 <a:cs typeface="Trebuchet MS" pitchFamily="34" charset="-120"/>
               </a:rPr>
-              <a:t>Convert</a:t>
+              <a:t>Grow</a:t>
             </a:r>
             <a:endParaRPr lang="en-US" sz="1800" dirty="0"/>
           </a:p>
@@ -3998,7 +3998,7 @@
                 <a:ea typeface="Calibri" pitchFamily="34" charset="-122"/>
                 <a:cs typeface="Calibri" pitchFamily="34" charset="-120"/>
               </a:rPr>
-              <a:t>Equip the rep with the target and the pitch</a:t>
+              <a:t>Owned brands grow; the engagement is tracked</a:t>
             </a:r>
             <a:endParaRPr lang="en-US" sz="1300" dirty="0"/>
           </a:p>
@@ -4057,7 +4057,7 @@
                 <a:ea typeface="Calibri" pitchFamily="34" charset="-122"/>
                 <a:cs typeface="Calibri" pitchFamily="34" charset="-120"/>
               </a:rPr>
-              <a:t>— one detail view unifies sales, stock, opportunities, crosses, and activity. Two tiers run the model: the OBCO seller channel (enablement) and the end customer (demand).</a:t>
+              <a:t>— one detail view unifies sales, stock, opportunities, crosses, and activity. Two tiers run the model: the WCO seller channel (push) and WCO customers (pull).</a:t>
             </a:r>
             <a:endParaRPr lang="en-US" sz="1500" dirty="0"/>
           </a:p>
@@ -4348,7 +4348,7 @@
                 <a:ea typeface="Trebuchet MS" pitchFamily="34" charset="-122"/>
                 <a:cs typeface="Trebuchet MS" pitchFamily="34" charset="-120"/>
               </a:rPr>
-              <a:t>Cross-reference engine</a:t>
+              <a:t>Cross database</a:t>
             </a:r>
             <a:endParaRPr lang="en-US" sz="1500" dirty="0"/>
           </a:p>
@@ -4390,7 +4390,7 @@
                 <a:ea typeface="Calibri" pitchFamily="34" charset="-122"/>
                 <a:cs typeface="Calibri" pitchFamily="34" charset="-120"/>
               </a:rPr>
-              <a:t>Competitor → owned-brand part mapping; living, searchable.</a:t>
+              <a:t>Competitive product → owned-brand part mapping; living, searchable.</a:t>
             </a:r>
             <a:endParaRPr lang="en-US" sz="1250" dirty="0"/>
           </a:p>
@@ -4515,7 +4515,7 @@
                 <a:ea typeface="Trebuchet MS" pitchFamily="34" charset="-122"/>
                 <a:cs typeface="Trebuchet MS" pitchFamily="34" charset="-120"/>
               </a:rPr>
-              <a:t>Conversion + supply</a:t>
+              <a:t>Signals + supply</a:t>
             </a:r>
             <a:endParaRPr lang="en-US" sz="1500" dirty="0"/>
           </a:p>
@@ -4557,7 +4557,7 @@
                 <a:ea typeface="Calibri" pitchFamily="34" charset="-122"/>
                 <a:cs typeface="Calibri" pitchFamily="34" charset="-120"/>
               </a:rPr>
-              <a:t>Targets ranked by margin upside, paired with a stock signal.</a:t>
+              <a:t>Where to show up — deals at risk, margin under pressure, stock signal.</a:t>
             </a:r>
             <a:endParaRPr lang="en-US" sz="1250" dirty="0"/>
           </a:p>
@@ -4724,7 +4724,7 @@
                 <a:ea typeface="Calibri" pitchFamily="34" charset="-122"/>
                 <a:cs typeface="Calibri" pitchFamily="34" charset="-120"/>
               </a:rPr>
-              <a:t>Opportunities, quotes, calls, demos, hardware evals.</a:t>
+              <a:t>OB engagement with WCO sellers and customers — quotes, calls, demos.</a:t>
             </a:r>
             <a:endParaRPr lang="en-US" sz="1250" dirty="0"/>
           </a:p>
@@ -4891,7 +4891,7 @@
                 <a:ea typeface="Calibri" pitchFamily="34" charset="-122"/>
                 <a:cs typeface="Calibri" pitchFamily="34" charset="-120"/>
               </a:rPr>
-              <a:t>Rep emails a note → structured records; datasheet cross-extraction.</a:t>
+              <a:t>A note → structured records; datasheet cross-extraction.</a:t>
             </a:r>
             <a:endParaRPr lang="en-US" sz="1250" dirty="0"/>
           </a:p>
@@ -5590,7 +5590,7 @@
                 <a:ea typeface="Calibri" pitchFamily="34" charset="-122"/>
                 <a:cs typeface="Calibri" pitchFamily="34" charset="-120"/>
               </a:rPr>
-              <a:t>No duplication or ownership of OBCO data</a:t>
+              <a:t>No duplication or ownership of WCO data</a:t>
             </a:r>
             <a:endParaRPr lang="en-US" sz="1400" dirty="0"/>
           </a:p>
@@ -5837,7 +5837,7 @@
                 <a:ea typeface="Calibri" pitchFamily="34" charset="-122"/>
                 <a:cs typeface="Calibri" pitchFamily="34" charset="-120"/>
               </a:rPr>
-              <a:t>This complements Power BI and introduces no new system of record for OBCO data.</a:t>
+              <a:t>This complements Power BI and introduces no new system of record for WCO data.</a:t>
             </a:r>
             <a:endParaRPr lang="en-US" sz="1500" dirty="0"/>
           </a:p>
@@ -7098,7 +7098,7 @@
                 <a:ea typeface="Calibri" pitchFamily="34" charset="-122"/>
                 <a:cs typeface="Calibri" pitchFamily="34" charset="-120"/>
               </a:rPr>
-              <a:t>Governed OBCO sales data incl. margin/cost — via certified datasets, Power BI, or the API layer. Defined Owned Brands user group; sole user at launch, expandable.</a:t>
+              <a:t>Governed WCO sales data incl. margin/cost — via certified datasets, Power BI, or the API layer. Defined user group: the Owned Brands sales team.</a:t>
             </a:r>
             <a:endParaRPr lang="en-US" sz="1300" dirty="0"/>
           </a:p>
@@ -7265,7 +7265,7 @@
                 <a:ea typeface="Calibri" pitchFamily="34" charset="-122"/>
                 <a:cs typeface="Calibri" pitchFamily="34" charset="-120"/>
               </a:rPr>
-              <a:t>Subscription / resource group under OBCO governance, Entra ID app registration, Azure OpenAI in-tenant, and a Power BI workspace with certified-dataset read access.</a:t>
+              <a:t>Subscription / resource group under WCO governance, Entra ID app registration, Azure OpenAI in-tenant, and a Power BI workspace with certified-dataset read access.</a:t>
             </a:r>
             <a:endParaRPr lang="en-US" sz="1300" dirty="0"/>
           </a:p>
@@ -7524,7 +7524,7 @@
                 <a:ea typeface="Trebuchet MS" pitchFamily="34" charset="-122"/>
                 <a:cs typeface="Trebuchet MS" pitchFamily="34" charset="-120"/>
               </a:rPr>
-              <a:t>Approve these and Owned Brands starts converting competitor sell-through into margin.</a:t>
+              <a:t>Approve these and the Owned Brands team can finally see the signals — and act on them.</a:t>
             </a:r>
             <a:endParaRPr lang="en-US" sz="1500" dirty="0"/>
           </a:p>

</xml_diff>

<commit_message>
docs: replace deck risk slide with data-flow + governance diagram
</commit_message>
<xml_diff>
--- a/Board pitch/Owned_Brands_Board_Deck.pptx
+++ b/Board pitch/Owned_Brands_Board_Deck.pptx
@@ -7391,7 +7391,7 @@
                 <a:ea typeface="Consolas" pitchFamily="34" charset="-122"/>
                 <a:cs typeface="Consolas" pitchFamily="34" charset="-120"/>
               </a:rPr>
-              <a:t>RISK &amp; GOVERNANCE</a:t>
+              <a:t>ARCHITECTURE &amp; GOVERNANCE</a:t>
             </a:r>
             <a:endParaRPr lang="en-US" sz="1100" dirty="0"/>
           </a:p>
@@ -7433,7 +7433,7 @@
                 <a:ea typeface="Trebuchet MS" pitchFamily="34" charset="-122"/>
                 <a:cs typeface="Trebuchet MS" pitchFamily="34" charset="-120"/>
               </a:rPr>
-              <a:t>Read-only and in-tenant: zero risk to CORE or USD</a:t>
+              <a:t>Read-only in, governed all the way through, the win out</a:t>
             </a:r>
             <a:endParaRPr lang="en-US" sz="2700" dirty="0"/>
           </a:p>
@@ -7447,16 +7447,16 @@
         </p:nvSpPr>
         <p:spPr>
           <a:xfrm>
-            <a:off x="548640" y="2148840"/>
-            <a:ext cx="5364328" cy="3108960"/>
+            <a:off x="548640" y="1828800"/>
+            <a:ext cx="2468880" cy="2514600"/>
           </a:xfrm>
           <a:prstGeom prst="roundRect">
             <a:avLst>
-              <a:gd name="adj" fmla="val 2647"/>
+              <a:gd name="adj" fmla="val 3333"/>
             </a:avLst>
           </a:prstGeom>
           <a:solidFill>
-            <a:srgbClr val="FBECEC"/>
+            <a:srgbClr val="F4F8F5"/>
           </a:solidFill>
           <a:ln w="12700">
             <a:solidFill>
@@ -7474,8 +7474,8 @@
         </p:nvSpPr>
         <p:spPr>
           <a:xfrm>
-            <a:off x="822960" y="2331720"/>
-            <a:ext cx="4815688" cy="365760"/>
+            <a:off x="749808" y="1993392"/>
+            <a:ext cx="2066544" cy="457200"/>
           </a:xfrm>
           <a:prstGeom prst="rect">
             <a:avLst/>
@@ -7491,17 +7491,17 @@
               <a:buNone/>
             </a:pPr>
             <a:r>
-              <a:rPr lang="en-US" sz="1600" b="1" dirty="0">
-                <a:solidFill>
-                  <a:srgbClr val="A6322B"/>
+              <a:rPr lang="en-US" sz="1500" b="1" dirty="0">
+                <a:solidFill>
+                  <a:srgbClr val="14241C"/>
                 </a:solidFill>
                 <a:latin typeface="Trebuchet MS" pitchFamily="34" charset="0"/>
                 <a:ea typeface="Trebuchet MS" pitchFamily="34" charset="-122"/>
                 <a:cs typeface="Trebuchet MS" pitchFamily="34" charset="-120"/>
               </a:rPr>
-              <a:t>What we will NOT do</a:t>
-            </a:r>
-            <a:endParaRPr lang="en-US" sz="1600" dirty="0"/>
+              <a:t>WCO sources</a:t>
+            </a:r>
+            <a:endParaRPr lang="en-US" sz="1500" dirty="0"/>
           </a:p>
         </p:txBody>
       </p:sp>
@@ -7513,137 +7513,77 @@
         </p:nvSpPr>
         <p:spPr>
           <a:xfrm>
-            <a:off x="822960" y="2788920"/>
-            <a:ext cx="4815688" cy="2286000"/>
-          </a:xfrm>
-          <a:prstGeom prst="rect">
-            <a:avLst/>
-          </a:prstGeom>
-          <a:noFill/>
-          <a:ln/>
-        </p:spPr>
-        <p:txBody>
-          <a:bodyPr wrap="square" rtlCol="0" anchor="ctr"/>
-          <a:lstStyle/>
-          <a:p>
-            <a:pPr marL="342900" indent="-342900">
+            <a:off x="749808" y="2542032"/>
+            <a:ext cx="2066544" cy="1097280"/>
+          </a:xfrm>
+          <a:prstGeom prst="rect">
+            <a:avLst/>
+          </a:prstGeom>
+          <a:noFill/>
+          <a:ln/>
+        </p:spPr>
+        <p:txBody>
+          <a:bodyPr wrap="square" rtlCol="0" anchor="ctr"/>
+          <a:lstStyle/>
+          <a:p>
+            <a:pPr indent="0" marL="0">
               <a:lnSpc>
                 <a:spcPct val="112000"/>
               </a:lnSpc>
-              <a:spcAft>
-                <a:spcPts val="600"/>
-              </a:spcAft>
-              <a:buSzPct val="100000"/>
-              <a:buChar char="✕"/>
-            </a:pPr>
-            <a:r>
-              <a:rPr lang="en-US" sz="1400" dirty="0">
-                <a:solidFill>
-                  <a:srgbClr val="14241C"/>
+              <a:buNone/>
+            </a:pPr>
+            <a:r>
+              <a:rPr lang="en-US" sz="1200" dirty="0">
+                <a:solidFill>
+                  <a:srgbClr val="586160"/>
                 </a:solidFill>
                 <a:latin typeface="Calibri" pitchFamily="34" charset="0"/>
                 <a:ea typeface="Calibri" pitchFamily="34" charset="-122"/>
                 <a:cs typeface="Calibri" pitchFamily="34" charset="-120"/>
               </a:rPr>
-              <a:t>No write / update / delete to CORE, USD, or any system of record</a:t>
-            </a:r>
-            <a:endParaRPr lang="en-US" sz="1400" dirty="0"/>
-          </a:p>
-          <a:p>
-            <a:pPr marL="342900" indent="-342900">
+              <a:t>CORE (ERP)</a:t>
+            </a:r>
+            <a:endParaRPr lang="en-US" sz="1200" dirty="0"/>
+          </a:p>
+          <a:p>
+            <a:pPr indent="0" marL="0">
               <a:lnSpc>
                 <a:spcPct val="112000"/>
               </a:lnSpc>
-              <a:spcAft>
-                <a:spcPts val="600"/>
-              </a:spcAft>
-              <a:buSzPct val="100000"/>
-              <a:buChar char="✕"/>
-            </a:pPr>
-            <a:r>
-              <a:rPr lang="en-US" sz="1400" dirty="0">
-                <a:solidFill>
-                  <a:srgbClr val="14241C"/>
+              <a:buNone/>
+            </a:pPr>
+            <a:r>
+              <a:rPr lang="en-US" sz="1200" dirty="0">
+                <a:solidFill>
+                  <a:srgbClr val="586160"/>
                 </a:solidFill>
                 <a:latin typeface="Calibri" pitchFamily="34" charset="0"/>
                 <a:ea typeface="Calibri" pitchFamily="34" charset="-122"/>
                 <a:cs typeface="Calibri" pitchFamily="34" charset="-120"/>
               </a:rPr>
-              <a:t>No direct production-database connectivity</a:t>
-            </a:r>
-            <a:endParaRPr lang="en-US" sz="1400" dirty="0"/>
-          </a:p>
-          <a:p>
-            <a:pPr marL="342900" indent="-342900">
+              <a:t>USD (CRM)</a:t>
+            </a:r>
+            <a:endParaRPr lang="en-US" sz="1200" dirty="0"/>
+          </a:p>
+          <a:p>
+            <a:pPr indent="0" marL="0">
               <a:lnSpc>
                 <a:spcPct val="112000"/>
               </a:lnSpc>
-              <a:spcAft>
-                <a:spcPts val="600"/>
-              </a:spcAft>
-              <a:buSzPct val="100000"/>
-              <a:buChar char="✕"/>
-            </a:pPr>
-            <a:r>
-              <a:rPr lang="en-US" sz="1400" dirty="0">
-                <a:solidFill>
-                  <a:srgbClr val="14241C"/>
+              <a:buNone/>
+            </a:pPr>
+            <a:r>
+              <a:rPr lang="en-US" sz="1200" dirty="0">
+                <a:solidFill>
+                  <a:srgbClr val="586160"/>
                 </a:solidFill>
                 <a:latin typeface="Calibri" pitchFamily="34" charset="0"/>
                 <a:ea typeface="Calibri" pitchFamily="34" charset="-122"/>
                 <a:cs typeface="Calibri" pitchFamily="34" charset="-120"/>
               </a:rPr>
-              <a:t>No duplication or ownership of WCO data</a:t>
-            </a:r>
-            <a:endParaRPr lang="en-US" sz="1400" dirty="0"/>
-          </a:p>
-          <a:p>
-            <a:pPr marL="342900" indent="-342900">
-              <a:lnSpc>
-                <a:spcPct val="112000"/>
-              </a:lnSpc>
-              <a:spcAft>
-                <a:spcPts val="600"/>
-              </a:spcAft>
-              <a:buSzPct val="100000"/>
-              <a:buChar char="✕"/>
-            </a:pPr>
-            <a:r>
-              <a:rPr lang="en-US" sz="1400" dirty="0">
-                <a:solidFill>
-                  <a:srgbClr val="14241C"/>
-                </a:solidFill>
-                <a:latin typeface="Calibri" pitchFamily="34" charset="0"/>
-                <a:ea typeface="Calibri" pitchFamily="34" charset="-122"/>
-                <a:cs typeface="Calibri" pitchFamily="34" charset="-120"/>
-              </a:rPr>
-              <a:t>No access outside the OB sales team</a:t>
-            </a:r>
-            <a:endParaRPr lang="en-US" sz="1400" dirty="0"/>
-          </a:p>
-          <a:p>
-            <a:pPr marL="342900" indent="-342900">
-              <a:lnSpc>
-                <a:spcPct val="112000"/>
-              </a:lnSpc>
-              <a:spcAft>
-                <a:spcPts val="600"/>
-              </a:spcAft>
-              <a:buSzPct val="100000"/>
-              <a:buChar char="✕"/>
-            </a:pPr>
-            <a:r>
-              <a:rPr lang="en-US" sz="1400" dirty="0">
-                <a:solidFill>
-                  <a:srgbClr val="14241C"/>
-                </a:solidFill>
-                <a:latin typeface="Calibri" pitchFamily="34" charset="0"/>
-                <a:ea typeface="Calibri" pitchFamily="34" charset="-122"/>
-                <a:cs typeface="Calibri" pitchFamily="34" charset="-120"/>
-              </a:rPr>
-              <a:t>No data egress outside the Microsoft / Azure boundary</a:t>
-            </a:r>
-            <a:endParaRPr lang="en-US" sz="1400" dirty="0"/>
+              <a:t>Inventory</a:t>
+            </a:r>
+            <a:endParaRPr lang="en-US" sz="1200" dirty="0"/>
           </a:p>
         </p:txBody>
       </p:sp>
@@ -7655,16 +7595,116 @@
         </p:nvSpPr>
         <p:spPr>
           <a:xfrm>
-            <a:off x="6278728" y="2148840"/>
-            <a:ext cx="5364328" cy="3108960"/>
+            <a:off x="749808" y="3867912"/>
+            <a:ext cx="2066544" cy="310896"/>
           </a:xfrm>
           <a:prstGeom prst="roundRect">
             <a:avLst>
-              <a:gd name="adj" fmla="val 2647"/>
+              <a:gd name="adj" fmla="val 17647"/>
             </a:avLst>
           </a:prstGeom>
           <a:solidFill>
             <a:srgbClr val="EAF4EE"/>
+          </a:solidFill>
+          <a:ln/>
+        </p:spPr>
+      </p:sp>
+      <p:sp>
+        <p:nvSpPr>
+          <p:cNvPr id="8" name="Text 6"/>
+          <p:cNvSpPr/>
+          <p:nvPr/>
+        </p:nvSpPr>
+        <p:spPr>
+          <a:xfrm>
+            <a:off x="749808" y="3867912"/>
+            <a:ext cx="2066544" cy="310896"/>
+          </a:xfrm>
+          <a:prstGeom prst="rect">
+            <a:avLst/>
+          </a:prstGeom>
+          <a:noFill/>
+          <a:ln/>
+        </p:spPr>
+        <p:txBody>
+          <a:bodyPr wrap="square" rtlCol="0" anchor="ctr"/>
+          <a:lstStyle/>
+          <a:p>
+            <a:pPr algn="ctr" indent="0" marL="0">
+              <a:buNone/>
+            </a:pPr>
+            <a:r>
+              <a:rPr lang="en-US" sz="1000" dirty="0">
+                <a:solidFill>
+                  <a:srgbClr val="1B7F4B"/>
+                </a:solidFill>
+                <a:latin typeface="Consolas" pitchFamily="34" charset="0"/>
+                <a:ea typeface="Consolas" pitchFamily="34" charset="-122"/>
+                <a:cs typeface="Consolas" pitchFamily="34" charset="-120"/>
+              </a:rPr>
+              <a:t>systems of record</a:t>
+            </a:r>
+            <a:endParaRPr lang="en-US" sz="1000" dirty="0"/>
+          </a:p>
+        </p:txBody>
+      </p:sp>
+      <p:sp>
+        <p:nvSpPr>
+          <p:cNvPr id="9" name="Text 7"/>
+          <p:cNvSpPr/>
+          <p:nvPr/>
+        </p:nvSpPr>
+        <p:spPr>
+          <a:xfrm>
+            <a:off x="3017520" y="1828800"/>
+            <a:ext cx="406298" cy="2514600"/>
+          </a:xfrm>
+          <a:prstGeom prst="rect">
+            <a:avLst/>
+          </a:prstGeom>
+          <a:noFill/>
+          <a:ln/>
+        </p:spPr>
+        <p:txBody>
+          <a:bodyPr wrap="square" rtlCol="0" anchor="ctr"/>
+          <a:lstStyle/>
+          <a:p>
+            <a:pPr algn="ctr" indent="0" marL="0">
+              <a:buNone/>
+            </a:pPr>
+            <a:r>
+              <a:rPr lang="en-US" sz="2200" b="1" dirty="0">
+                <a:solidFill>
+                  <a:srgbClr val="37B26B"/>
+                </a:solidFill>
+                <a:latin typeface="Consolas" pitchFamily="34" charset="0"/>
+                <a:ea typeface="Consolas" pitchFamily="34" charset="-122"/>
+                <a:cs typeface="Consolas" pitchFamily="34" charset="-120"/>
+              </a:rPr>
+              <a:t>→</a:t>
+            </a:r>
+            <a:endParaRPr lang="en-US" sz="2200" dirty="0"/>
+          </a:p>
+        </p:txBody>
+      </p:sp>
+      <p:sp>
+        <p:nvSpPr>
+          <p:cNvPr id="10" name="Shape 8"/>
+          <p:cNvSpPr/>
+          <p:nvPr/>
+        </p:nvSpPr>
+        <p:spPr>
+          <a:xfrm>
+            <a:off x="3423818" y="1828800"/>
+            <a:ext cx="2468880" cy="2514600"/>
+          </a:xfrm>
+          <a:prstGeom prst="roundRect">
+            <a:avLst>
+              <a:gd name="adj" fmla="val 3333"/>
+            </a:avLst>
+          </a:prstGeom>
+          <a:solidFill>
+            <a:srgbClr val="F4F8F5"/>
           </a:solidFill>
           <a:ln w="12700">
             <a:solidFill>
@@ -7676,14 +7716,14 @@
       </p:sp>
       <p:sp>
         <p:nvSpPr>
-          <p:cNvPr id="8" name="Text 6"/>
-          <p:cNvSpPr/>
-          <p:nvPr/>
-        </p:nvSpPr>
-        <p:spPr>
-          <a:xfrm>
-            <a:off x="6553048" y="2331720"/>
-            <a:ext cx="4815688" cy="365760"/>
+          <p:cNvPr id="11" name="Text 9"/>
+          <p:cNvSpPr/>
+          <p:nvPr/>
+        </p:nvSpPr>
+        <p:spPr>
+          <a:xfrm>
+            <a:off x="3624986" y="1993392"/>
+            <a:ext cx="2066544" cy="457200"/>
           </a:xfrm>
           <a:prstGeom prst="rect">
             <a:avLst/>
@@ -7699,172 +7739,511 @@
               <a:buNone/>
             </a:pPr>
             <a:r>
-              <a:rPr lang="en-US" sz="1600" b="1" dirty="0">
-                <a:solidFill>
-                  <a:srgbClr val="1B7F4B"/>
+              <a:rPr lang="en-US" sz="1500" b="1" dirty="0">
+                <a:solidFill>
+                  <a:srgbClr val="14241C"/>
                 </a:solidFill>
                 <a:latin typeface="Trebuchet MS" pitchFamily="34" charset="0"/>
                 <a:ea typeface="Trebuchet MS" pitchFamily="34" charset="-122"/>
                 <a:cs typeface="Trebuchet MS" pitchFamily="34" charset="-120"/>
               </a:rPr>
-              <a:t>How it’s governed</a:t>
-            </a:r>
-            <a:endParaRPr lang="en-US" sz="1600" dirty="0"/>
-          </a:p>
-        </p:txBody>
-      </p:sp>
-      <p:sp>
-        <p:nvSpPr>
-          <p:cNvPr id="9" name="Text 7"/>
-          <p:cNvSpPr/>
-          <p:nvPr/>
-        </p:nvSpPr>
-        <p:spPr>
-          <a:xfrm>
-            <a:off x="6553048" y="2834640"/>
-            <a:ext cx="4815688" cy="2194560"/>
-          </a:xfrm>
-          <a:prstGeom prst="rect">
-            <a:avLst/>
-          </a:prstGeom>
-          <a:noFill/>
-          <a:ln/>
-        </p:spPr>
-        <p:txBody>
-          <a:bodyPr wrap="square" rtlCol="0" anchor="ctr"/>
-          <a:lstStyle/>
-          <a:p>
-            <a:pPr marL="342900" indent="-342900">
+              <a:t>Governed access</a:t>
+            </a:r>
+            <a:endParaRPr lang="en-US" sz="1500" dirty="0"/>
+          </a:p>
+        </p:txBody>
+      </p:sp>
+      <p:sp>
+        <p:nvSpPr>
+          <p:cNvPr id="12" name="Text 10"/>
+          <p:cNvSpPr/>
+          <p:nvPr/>
+        </p:nvSpPr>
+        <p:spPr>
+          <a:xfrm>
+            <a:off x="3624986" y="2542032"/>
+            <a:ext cx="2066544" cy="1097280"/>
+          </a:xfrm>
+          <a:prstGeom prst="rect">
+            <a:avLst/>
+          </a:prstGeom>
+          <a:noFill/>
+          <a:ln/>
+        </p:spPr>
+        <p:txBody>
+          <a:bodyPr wrap="square" rtlCol="0" anchor="ctr"/>
+          <a:lstStyle/>
+          <a:p>
+            <a:pPr indent="0" marL="0">
               <a:lnSpc>
-                <a:spcPct val="115000"/>
+                <a:spcPct val="112000"/>
               </a:lnSpc>
-              <a:spcAft>
-                <a:spcPts val="800"/>
-              </a:spcAft>
-              <a:buSzPct val="100000"/>
-              <a:buChar char="✓"/>
-            </a:pPr>
-            <a:r>
-              <a:rPr lang="en-US" sz="1400" dirty="0">
-                <a:solidFill>
-                  <a:srgbClr val="14241C"/>
+              <a:buNone/>
+            </a:pPr>
+            <a:r>
+              <a:rPr lang="en-US" sz="1200" dirty="0">
+                <a:solidFill>
+                  <a:srgbClr val="586160"/>
                 </a:solidFill>
                 <a:latin typeface="Calibri" pitchFamily="34" charset="0"/>
                 <a:ea typeface="Calibri" pitchFamily="34" charset="-122"/>
                 <a:cs typeface="Calibri" pitchFamily="34" charset="-120"/>
               </a:rPr>
-              <a:t>Azure-native: App Service / Functions + isolated Azure SQL</a:t>
-            </a:r>
-            <a:endParaRPr lang="en-US" sz="1400" dirty="0"/>
-          </a:p>
-          <a:p>
-            <a:pPr marL="342900" indent="-342900">
+              <a:t>Certified datasets,</a:t>
+            </a:r>
+            <a:endParaRPr lang="en-US" sz="1200" dirty="0"/>
+          </a:p>
+          <a:p>
+            <a:pPr indent="0" marL="0">
               <a:lnSpc>
-                <a:spcPct val="115000"/>
+                <a:spcPct val="112000"/>
               </a:lnSpc>
-              <a:spcAft>
-                <a:spcPts val="800"/>
-              </a:spcAft>
-              <a:buSzPct val="100000"/>
-              <a:buChar char="✓"/>
-            </a:pPr>
-            <a:r>
-              <a:rPr lang="en-US" sz="1400" dirty="0">
-                <a:solidFill>
-                  <a:srgbClr val="14241C"/>
+              <a:buNone/>
+            </a:pPr>
+            <a:r>
+              <a:rPr lang="en-US" sz="1200" dirty="0">
+                <a:solidFill>
+                  <a:srgbClr val="586160"/>
                 </a:solidFill>
                 <a:latin typeface="Calibri" pitchFamily="34" charset="0"/>
                 <a:ea typeface="Calibri" pitchFamily="34" charset="-122"/>
                 <a:cs typeface="Calibri" pitchFamily="34" charset="-120"/>
               </a:rPr>
-              <a:t>Entra ID SSO, application RBAC, territory row-level security</a:t>
-            </a:r>
-            <a:endParaRPr lang="en-US" sz="1400" dirty="0"/>
-          </a:p>
-          <a:p>
-            <a:pPr marL="342900" indent="-342900">
+              <a:t>Power BI, or the</a:t>
+            </a:r>
+            <a:endParaRPr lang="en-US" sz="1200" dirty="0"/>
+          </a:p>
+          <a:p>
+            <a:pPr indent="0" marL="0">
               <a:lnSpc>
-                <a:spcPct val="115000"/>
+                <a:spcPct val="112000"/>
               </a:lnSpc>
-              <a:spcAft>
-                <a:spcPts val="800"/>
-              </a:spcAft>
-              <a:buSzPct val="100000"/>
-              <a:buChar char="✓"/>
-            </a:pPr>
-            <a:r>
-              <a:rPr lang="en-US" sz="1400" dirty="0">
-                <a:solidFill>
-                  <a:srgbClr val="14241C"/>
+              <a:buNone/>
+            </a:pPr>
+            <a:r>
+              <a:rPr lang="en-US" sz="1200" dirty="0">
+                <a:solidFill>
+                  <a:srgbClr val="586160"/>
                 </a:solidFill>
                 <a:latin typeface="Calibri" pitchFamily="34" charset="0"/>
                 <a:ea typeface="Calibri" pitchFamily="34" charset="-122"/>
                 <a:cs typeface="Calibri" pitchFamily="34" charset="-120"/>
               </a:rPr>
-              <a:t>Embedded certified Power BI, no dataset duplication</a:t>
-            </a:r>
-            <a:endParaRPr lang="en-US" sz="1400" dirty="0"/>
-          </a:p>
-          <a:p>
-            <a:pPr marL="342900" indent="-342900">
+              <a:t>enterprise API layer</a:t>
+            </a:r>
+            <a:endParaRPr lang="en-US" sz="1200" dirty="0"/>
+          </a:p>
+        </p:txBody>
+      </p:sp>
+      <p:sp>
+        <p:nvSpPr>
+          <p:cNvPr id="13" name="Shape 11"/>
+          <p:cNvSpPr/>
+          <p:nvPr/>
+        </p:nvSpPr>
+        <p:spPr>
+          <a:xfrm>
+            <a:off x="3624986" y="3867912"/>
+            <a:ext cx="2066544" cy="310896"/>
+          </a:xfrm>
+          <a:prstGeom prst="roundRect">
+            <a:avLst>
+              <a:gd name="adj" fmla="val 17647"/>
+            </a:avLst>
+          </a:prstGeom>
+          <a:solidFill>
+            <a:srgbClr val="1B7F4B"/>
+          </a:solidFill>
+          <a:ln/>
+        </p:spPr>
+      </p:sp>
+      <p:sp>
+        <p:nvSpPr>
+          <p:cNvPr id="14" name="Text 12"/>
+          <p:cNvSpPr/>
+          <p:nvPr/>
+        </p:nvSpPr>
+        <p:spPr>
+          <a:xfrm>
+            <a:off x="3624986" y="3867912"/>
+            <a:ext cx="2066544" cy="310896"/>
+          </a:xfrm>
+          <a:prstGeom prst="rect">
+            <a:avLst/>
+          </a:prstGeom>
+          <a:noFill/>
+          <a:ln/>
+        </p:spPr>
+        <p:txBody>
+          <a:bodyPr wrap="square" rtlCol="0" anchor="ctr"/>
+          <a:lstStyle/>
+          <a:p>
+            <a:pPr algn="ctr" indent="0" marL="0">
+              <a:buNone/>
+            </a:pPr>
+            <a:r>
+              <a:rPr lang="en-US" sz="1000" b="1" dirty="0">
+                <a:solidFill>
+                  <a:srgbClr val="FFFFFF"/>
+                </a:solidFill>
+                <a:latin typeface="Consolas" pitchFamily="34" charset="0"/>
+                <a:ea typeface="Consolas" pitchFamily="34" charset="-122"/>
+                <a:cs typeface="Consolas" pitchFamily="34" charset="-120"/>
+              </a:rPr>
+              <a:t>read-only</a:t>
+            </a:r>
+            <a:endParaRPr lang="en-US" sz="1000" dirty="0"/>
+          </a:p>
+        </p:txBody>
+      </p:sp>
+      <p:sp>
+        <p:nvSpPr>
+          <p:cNvPr id="15" name="Text 13"/>
+          <p:cNvSpPr/>
+          <p:nvPr/>
+        </p:nvSpPr>
+        <p:spPr>
+          <a:xfrm>
+            <a:off x="5892698" y="1828800"/>
+            <a:ext cx="406298" cy="2514600"/>
+          </a:xfrm>
+          <a:prstGeom prst="rect">
+            <a:avLst/>
+          </a:prstGeom>
+          <a:noFill/>
+          <a:ln/>
+        </p:spPr>
+        <p:txBody>
+          <a:bodyPr wrap="square" rtlCol="0" anchor="ctr"/>
+          <a:lstStyle/>
+          <a:p>
+            <a:pPr algn="ctr" indent="0" marL="0">
+              <a:buNone/>
+            </a:pPr>
+            <a:r>
+              <a:rPr lang="en-US" sz="2200" b="1" dirty="0">
+                <a:solidFill>
+                  <a:srgbClr val="37B26B"/>
+                </a:solidFill>
+                <a:latin typeface="Consolas" pitchFamily="34" charset="0"/>
+                <a:ea typeface="Consolas" pitchFamily="34" charset="-122"/>
+                <a:cs typeface="Consolas" pitchFamily="34" charset="-120"/>
+              </a:rPr>
+              <a:t>→</a:t>
+            </a:r>
+            <a:endParaRPr lang="en-US" sz="2200" dirty="0"/>
+          </a:p>
+        </p:txBody>
+      </p:sp>
+      <p:sp>
+        <p:nvSpPr>
+          <p:cNvPr id="16" name="Shape 14"/>
+          <p:cNvSpPr/>
+          <p:nvPr/>
+        </p:nvSpPr>
+        <p:spPr>
+          <a:xfrm>
+            <a:off x="6298997" y="1828800"/>
+            <a:ext cx="2468880" cy="2514600"/>
+          </a:xfrm>
+          <a:prstGeom prst="roundRect">
+            <a:avLst>
+              <a:gd name="adj" fmla="val 3333"/>
+            </a:avLst>
+          </a:prstGeom>
+          <a:solidFill>
+            <a:srgbClr val="F4F8F5"/>
+          </a:solidFill>
+          <a:ln w="12700">
+            <a:solidFill>
+              <a:srgbClr val="DCE5DF"/>
+            </a:solidFill>
+            <a:prstDash val="solid"/>
+          </a:ln>
+        </p:spPr>
+      </p:sp>
+      <p:sp>
+        <p:nvSpPr>
+          <p:cNvPr id="17" name="Text 15"/>
+          <p:cNvSpPr/>
+          <p:nvPr/>
+        </p:nvSpPr>
+        <p:spPr>
+          <a:xfrm>
+            <a:off x="6500165" y="1993392"/>
+            <a:ext cx="2066544" cy="457200"/>
+          </a:xfrm>
+          <a:prstGeom prst="rect">
+            <a:avLst/>
+          </a:prstGeom>
+          <a:noFill/>
+          <a:ln/>
+        </p:spPr>
+        <p:txBody>
+          <a:bodyPr wrap="square" rtlCol="0" anchor="ctr"/>
+          <a:lstStyle/>
+          <a:p>
+            <a:pPr indent="0" marL="0">
+              <a:buNone/>
+            </a:pPr>
+            <a:r>
+              <a:rPr lang="en-US" sz="1500" b="1" dirty="0">
+                <a:solidFill>
+                  <a:srgbClr val="14241C"/>
+                </a:solidFill>
+                <a:latin typeface="Trebuchet MS" pitchFamily="34" charset="0"/>
+                <a:ea typeface="Trebuchet MS" pitchFamily="34" charset="-122"/>
+                <a:cs typeface="Trebuchet MS" pitchFamily="34" charset="-120"/>
+              </a:rPr>
+              <a:t>OB_Datavers</a:t>
+            </a:r>
+            <a:endParaRPr lang="en-US" sz="1500" dirty="0"/>
+          </a:p>
+        </p:txBody>
+      </p:sp>
+      <p:sp>
+        <p:nvSpPr>
+          <p:cNvPr id="18" name="Text 16"/>
+          <p:cNvSpPr/>
+          <p:nvPr/>
+        </p:nvSpPr>
+        <p:spPr>
+          <a:xfrm>
+            <a:off x="6500165" y="2542032"/>
+            <a:ext cx="2066544" cy="1097280"/>
+          </a:xfrm>
+          <a:prstGeom prst="rect">
+            <a:avLst/>
+          </a:prstGeom>
+          <a:noFill/>
+          <a:ln/>
+        </p:spPr>
+        <p:txBody>
+          <a:bodyPr wrap="square" rtlCol="0" anchor="ctr"/>
+          <a:lstStyle/>
+          <a:p>
+            <a:pPr indent="0" marL="0">
               <a:lnSpc>
-                <a:spcPct val="115000"/>
+                <a:spcPct val="112000"/>
               </a:lnSpc>
-              <a:spcAft>
-                <a:spcPts val="800"/>
-              </a:spcAft>
-              <a:buSzPct val="100000"/>
-              <a:buChar char="✓"/>
-            </a:pPr>
-            <a:r>
-              <a:rPr lang="en-US" sz="1400" dirty="0">
-                <a:solidFill>
-                  <a:srgbClr val="14241C"/>
+              <a:buNone/>
+            </a:pPr>
+            <a:r>
+              <a:rPr lang="en-US" sz="1200" dirty="0">
+                <a:solidFill>
+                  <a:srgbClr val="586160"/>
                 </a:solidFill>
                 <a:latin typeface="Calibri" pitchFamily="34" charset="0"/>
                 <a:ea typeface="Calibri" pitchFamily="34" charset="-122"/>
                 <a:cs typeface="Calibri" pitchFamily="34" charset="-120"/>
               </a:rPr>
-              <a:t>Azure OpenAI in-tenant; margin/cost handled as Confidential</a:t>
-            </a:r>
-            <a:endParaRPr lang="en-US" sz="1400" dirty="0"/>
-          </a:p>
-        </p:txBody>
-      </p:sp>
-      <p:sp>
-        <p:nvSpPr>
-          <p:cNvPr id="10" name="Text 8"/>
-          <p:cNvSpPr/>
-          <p:nvPr/>
-        </p:nvSpPr>
-        <p:spPr>
-          <a:xfrm>
-            <a:off x="548640" y="5440680"/>
-            <a:ext cx="11094415" cy="365760"/>
-          </a:xfrm>
-          <a:prstGeom prst="rect">
-            <a:avLst/>
-          </a:prstGeom>
-          <a:noFill/>
-          <a:ln/>
-        </p:spPr>
-        <p:txBody>
-          <a:bodyPr wrap="square" rtlCol="0" anchor="ctr"/>
-          <a:lstStyle/>
+              <a:t>Cross-reference engine</a:t>
+            </a:r>
+            <a:endParaRPr lang="en-US" sz="1200" dirty="0"/>
+          </a:p>
           <a:p>
             <a:pPr indent="0" marL="0">
-              <a:buNone/>
-            </a:pPr>
-            <a:r>
-              <a:rPr lang="en-US" sz="1500" i="1" dirty="0">
-                <a:solidFill>
-                  <a:srgbClr val="1B7F4B"/>
+              <a:lnSpc>
+                <a:spcPct val="112000"/>
+              </a:lnSpc>
+              <a:buNone/>
+            </a:pPr>
+            <a:r>
+              <a:rPr lang="en-US" sz="1200" dirty="0">
+                <a:solidFill>
+                  <a:srgbClr val="586160"/>
                 </a:solidFill>
                 <a:latin typeface="Calibri" pitchFamily="34" charset="0"/>
                 <a:ea typeface="Calibri" pitchFamily="34" charset="-122"/>
                 <a:cs typeface="Calibri" pitchFamily="34" charset="-120"/>
               </a:rPr>
-              <a:t>This complements Power BI and introduces no new system of record for WCO data.</a:t>
+              <a:t>Activity store, Azure SQL</a:t>
+            </a:r>
+            <a:endParaRPr lang="en-US" sz="1200" dirty="0"/>
+          </a:p>
+          <a:p>
+            <a:pPr indent="0" marL="0">
+              <a:lnSpc>
+                <a:spcPct val="112000"/>
+              </a:lnSpc>
+              <a:buNone/>
+            </a:pPr>
+            <a:r>
+              <a:rPr lang="en-US" sz="1200" dirty="0">
+                <a:solidFill>
+                  <a:srgbClr val="586160"/>
+                </a:solidFill>
+                <a:latin typeface="Calibri" pitchFamily="34" charset="0"/>
+                <a:ea typeface="Calibri" pitchFamily="34" charset="-122"/>
+                <a:cs typeface="Calibri" pitchFamily="34" charset="-120"/>
+              </a:rPr>
+              <a:t>AI layer, Azure OpenAI</a:t>
+            </a:r>
+            <a:endParaRPr lang="en-US" sz="1200" dirty="0"/>
+          </a:p>
+        </p:txBody>
+      </p:sp>
+      <p:sp>
+        <p:nvSpPr>
+          <p:cNvPr id="19" name="Shape 17"/>
+          <p:cNvSpPr/>
+          <p:nvPr/>
+        </p:nvSpPr>
+        <p:spPr>
+          <a:xfrm>
+            <a:off x="6500165" y="3867912"/>
+            <a:ext cx="2066544" cy="310896"/>
+          </a:xfrm>
+          <a:prstGeom prst="roundRect">
+            <a:avLst>
+              <a:gd name="adj" fmla="val 17647"/>
+            </a:avLst>
+          </a:prstGeom>
+          <a:solidFill>
+            <a:srgbClr val="EAF4EE"/>
+          </a:solidFill>
+          <a:ln/>
+        </p:spPr>
+      </p:sp>
+      <p:sp>
+        <p:nvSpPr>
+          <p:cNvPr id="20" name="Text 18"/>
+          <p:cNvSpPr/>
+          <p:nvPr/>
+        </p:nvSpPr>
+        <p:spPr>
+          <a:xfrm>
+            <a:off x="6500165" y="3867912"/>
+            <a:ext cx="2066544" cy="310896"/>
+          </a:xfrm>
+          <a:prstGeom prst="rect">
+            <a:avLst/>
+          </a:prstGeom>
+          <a:noFill/>
+          <a:ln/>
+        </p:spPr>
+        <p:txBody>
+          <a:bodyPr wrap="square" rtlCol="0" anchor="ctr"/>
+          <a:lstStyle/>
+          <a:p>
+            <a:pPr algn="ctr" indent="0" marL="0">
+              <a:buNone/>
+            </a:pPr>
+            <a:r>
+              <a:rPr lang="en-US" sz="1000" dirty="0">
+                <a:solidFill>
+                  <a:srgbClr val="1B7F4B"/>
+                </a:solidFill>
+                <a:latin typeface="Consolas" pitchFamily="34" charset="0"/>
+                <a:ea typeface="Consolas" pitchFamily="34" charset="-122"/>
+                <a:cs typeface="Consolas" pitchFamily="34" charset="-120"/>
+              </a:rPr>
+              <a:t>isolated, in-tenant</a:t>
+            </a:r>
+            <a:endParaRPr lang="en-US" sz="1000" dirty="0"/>
+          </a:p>
+        </p:txBody>
+      </p:sp>
+      <p:sp>
+        <p:nvSpPr>
+          <p:cNvPr id="21" name="Text 19"/>
+          <p:cNvSpPr/>
+          <p:nvPr/>
+        </p:nvSpPr>
+        <p:spPr>
+          <a:xfrm>
+            <a:off x="8767877" y="1828800"/>
+            <a:ext cx="406298" cy="2514600"/>
+          </a:xfrm>
+          <a:prstGeom prst="rect">
+            <a:avLst/>
+          </a:prstGeom>
+          <a:noFill/>
+          <a:ln/>
+        </p:spPr>
+        <p:txBody>
+          <a:bodyPr wrap="square" rtlCol="0" anchor="ctr"/>
+          <a:lstStyle/>
+          <a:p>
+            <a:pPr algn="ctr" indent="0" marL="0">
+              <a:buNone/>
+            </a:pPr>
+            <a:r>
+              <a:rPr lang="en-US" sz="2200" b="1" dirty="0">
+                <a:solidFill>
+                  <a:srgbClr val="37B26B"/>
+                </a:solidFill>
+                <a:latin typeface="Consolas" pitchFamily="34" charset="0"/>
+                <a:ea typeface="Consolas" pitchFamily="34" charset="-122"/>
+                <a:cs typeface="Consolas" pitchFamily="34" charset="-120"/>
+              </a:rPr>
+              <a:t>→</a:t>
+            </a:r>
+            <a:endParaRPr lang="en-US" sz="2200" dirty="0"/>
+          </a:p>
+        </p:txBody>
+      </p:sp>
+      <p:sp>
+        <p:nvSpPr>
+          <p:cNvPr id="22" name="Shape 20"/>
+          <p:cNvSpPr/>
+          <p:nvPr/>
+        </p:nvSpPr>
+        <p:spPr>
+          <a:xfrm>
+            <a:off x="9174175" y="1828800"/>
+            <a:ext cx="2468880" cy="2514600"/>
+          </a:xfrm>
+          <a:prstGeom prst="roundRect">
+            <a:avLst>
+              <a:gd name="adj" fmla="val 3333"/>
+            </a:avLst>
+          </a:prstGeom>
+          <a:solidFill>
+            <a:srgbClr val="1B7F4B"/>
+          </a:solidFill>
+          <a:ln w="12700">
+            <a:solidFill>
+              <a:srgbClr val="DCE5DF"/>
+            </a:solidFill>
+            <a:prstDash val="solid"/>
+          </a:ln>
+        </p:spPr>
+      </p:sp>
+      <p:sp>
+        <p:nvSpPr>
+          <p:cNvPr id="23" name="Text 21"/>
+          <p:cNvSpPr/>
+          <p:nvPr/>
+        </p:nvSpPr>
+        <p:spPr>
+          <a:xfrm>
+            <a:off x="9375343" y="1993392"/>
+            <a:ext cx="2066544" cy="457200"/>
+          </a:xfrm>
+          <a:prstGeom prst="rect">
+            <a:avLst/>
+          </a:prstGeom>
+          <a:noFill/>
+          <a:ln/>
+        </p:spPr>
+        <p:txBody>
+          <a:bodyPr wrap="square" rtlCol="0" anchor="ctr"/>
+          <a:lstStyle/>
+          <a:p>
+            <a:pPr indent="0" marL="0">
+              <a:buNone/>
+            </a:pPr>
+            <a:r>
+              <a:rPr lang="en-US" sz="1500" b="1" dirty="0">
+                <a:solidFill>
+                  <a:srgbClr val="FFFFFF"/>
+                </a:solidFill>
+                <a:latin typeface="Trebuchet MS" pitchFamily="34" charset="0"/>
+                <a:ea typeface="Trebuchet MS" pitchFamily="34" charset="-122"/>
+                <a:cs typeface="Trebuchet MS" pitchFamily="34" charset="-120"/>
+              </a:rPr>
+              <a:t>Dashboard, then the win</a:t>
             </a:r>
             <a:endParaRPr lang="en-US" sz="1500" dirty="0"/>
           </a:p>
@@ -7872,7 +8251,242 @@
       </p:sp>
       <p:sp>
         <p:nvSpPr>
-          <p:cNvPr id="11" name="Text 9"/>
+          <p:cNvPr id="24" name="Text 22"/>
+          <p:cNvSpPr/>
+          <p:nvPr/>
+        </p:nvSpPr>
+        <p:spPr>
+          <a:xfrm>
+            <a:off x="9375343" y="2542032"/>
+            <a:ext cx="2066544" cy="1097280"/>
+          </a:xfrm>
+          <a:prstGeom prst="rect">
+            <a:avLst/>
+          </a:prstGeom>
+          <a:noFill/>
+          <a:ln/>
+        </p:spPr>
+        <p:txBody>
+          <a:bodyPr wrap="square" rtlCol="0" anchor="ctr"/>
+          <a:lstStyle/>
+          <a:p>
+            <a:pPr indent="0" marL="0">
+              <a:lnSpc>
+                <a:spcPct val="112000"/>
+              </a:lnSpc>
+              <a:buNone/>
+            </a:pPr>
+            <a:r>
+              <a:rPr lang="en-US" sz="1200" dirty="0">
+                <a:solidFill>
+                  <a:srgbClr val="EAF4EE"/>
+                </a:solidFill>
+                <a:latin typeface="Calibri" pitchFamily="34" charset="0"/>
+                <a:ea typeface="Calibri" pitchFamily="34" charset="-122"/>
+                <a:cs typeface="Calibri" pitchFamily="34" charset="-120"/>
+              </a:rPr>
+              <a:t>Embedded Power BI</a:t>
+            </a:r>
+            <a:endParaRPr lang="en-US" sz="1200" dirty="0"/>
+          </a:p>
+          <a:p>
+            <a:pPr indent="0" marL="0">
+              <a:lnSpc>
+                <a:spcPct val="112000"/>
+              </a:lnSpc>
+              <a:buNone/>
+            </a:pPr>
+            <a:r>
+              <a:rPr lang="en-US" sz="1200" dirty="0">
+                <a:solidFill>
+                  <a:srgbClr val="EAF4EE"/>
+                </a:solidFill>
+                <a:latin typeface="Calibri" pitchFamily="34" charset="0"/>
+                <a:ea typeface="Calibri" pitchFamily="34" charset="-122"/>
+                <a:cs typeface="Calibri" pitchFamily="34" charset="-120"/>
+              </a:rPr>
+              <a:t>Seller signals surfaced</a:t>
+            </a:r>
+            <a:endParaRPr lang="en-US" sz="1200" dirty="0"/>
+          </a:p>
+          <a:p>
+            <a:pPr indent="0" marL="0">
+              <a:lnSpc>
+                <a:spcPct val="112000"/>
+              </a:lnSpc>
+              <a:buNone/>
+            </a:pPr>
+            <a:r>
+              <a:rPr lang="en-US" sz="1200" dirty="0">
+                <a:solidFill>
+                  <a:srgbClr val="EAF4EE"/>
+                </a:solidFill>
+                <a:latin typeface="Calibri" pitchFamily="34" charset="0"/>
+                <a:ea typeface="Calibri" pitchFamily="34" charset="-122"/>
+                <a:cs typeface="Calibri" pitchFamily="34" charset="-120"/>
+              </a:rPr>
+              <a:t>Spec owned brands, win</a:t>
+            </a:r>
+            <a:endParaRPr lang="en-US" sz="1200" dirty="0"/>
+          </a:p>
+        </p:txBody>
+      </p:sp>
+      <p:sp>
+        <p:nvSpPr>
+          <p:cNvPr id="25" name="Shape 23"/>
+          <p:cNvSpPr/>
+          <p:nvPr/>
+        </p:nvSpPr>
+        <p:spPr>
+          <a:xfrm>
+            <a:off x="548640" y="4709160"/>
+            <a:ext cx="11094415" cy="457200"/>
+          </a:xfrm>
+          <a:prstGeom prst="roundRect">
+            <a:avLst>
+              <a:gd name="adj" fmla="val 16000"/>
+            </a:avLst>
+          </a:prstGeom>
+          <a:solidFill>
+            <a:srgbClr val="10402A"/>
+          </a:solidFill>
+          <a:ln/>
+        </p:spPr>
+      </p:sp>
+      <p:sp>
+        <p:nvSpPr>
+          <p:cNvPr id="26" name="Text 24"/>
+          <p:cNvSpPr/>
+          <p:nvPr/>
+        </p:nvSpPr>
+        <p:spPr>
+          <a:xfrm>
+            <a:off x="548640" y="4709160"/>
+            <a:ext cx="11094415" cy="457200"/>
+          </a:xfrm>
+          <a:prstGeom prst="rect">
+            <a:avLst/>
+          </a:prstGeom>
+          <a:noFill/>
+          <a:ln/>
+        </p:spPr>
+        <p:txBody>
+          <a:bodyPr wrap="square" rtlCol="0" anchor="ctr"/>
+          <a:lstStyle/>
+          <a:p>
+            <a:pPr algn="ctr" indent="0" marL="0">
+              <a:buNone/>
+            </a:pPr>
+            <a:r>
+              <a:rPr lang="en-US" sz="1300" dirty="0">
+                <a:solidFill>
+                  <a:srgbClr val="FFFFFF"/>
+                </a:solidFill>
+                <a:latin typeface="Calibri" pitchFamily="34" charset="0"/>
+                <a:ea typeface="Calibri" pitchFamily="34" charset="-122"/>
+                <a:cs typeface="Calibri" pitchFamily="34" charset="-120"/>
+              </a:rPr>
+              <a:t>Entra ID SSO   ·   RBAC + row-level security   ·   stays inside the Microsoft / Azure boundary, no egress</a:t>
+            </a:r>
+            <a:endParaRPr lang="en-US" sz="1300" dirty="0"/>
+          </a:p>
+        </p:txBody>
+      </p:sp>
+      <p:sp>
+        <p:nvSpPr>
+          <p:cNvPr id="27" name="Text 25"/>
+          <p:cNvSpPr/>
+          <p:nvPr/>
+        </p:nvSpPr>
+        <p:spPr>
+          <a:xfrm>
+            <a:off x="548640" y="5303520"/>
+            <a:ext cx="11094415" cy="320040"/>
+          </a:xfrm>
+          <a:prstGeom prst="rect">
+            <a:avLst/>
+          </a:prstGeom>
+          <a:noFill/>
+          <a:ln/>
+        </p:spPr>
+        <p:txBody>
+          <a:bodyPr wrap="square" rtlCol="0" anchor="ctr"/>
+          <a:lstStyle/>
+          <a:p>
+            <a:pPr algn="ctr" indent="0" marL="0">
+              <a:buNone/>
+            </a:pPr>
+            <a:r>
+              <a:rPr lang="en-US" sz="1300" b="1" dirty="0">
+                <a:solidFill>
+                  <a:srgbClr val="A6322B"/>
+                </a:solidFill>
+                <a:latin typeface="Calibri" pitchFamily="34" charset="0"/>
+                <a:ea typeface="Calibri" pitchFamily="34" charset="-122"/>
+                <a:cs typeface="Calibri" pitchFamily="34" charset="-120"/>
+              </a:rPr>
+              <a:t>Not doing: </a:t>
+            </a:r>
+            <a:pPr algn="ctr" indent="0" marL="0">
+              <a:buNone/>
+            </a:pPr>
+            <a:r>
+              <a:rPr lang="en-US" sz="1300" dirty="0">
+                <a:solidFill>
+                  <a:srgbClr val="586160"/>
+                </a:solidFill>
+                <a:latin typeface="Calibri" pitchFamily="34" charset="0"/>
+                <a:ea typeface="Calibri" pitchFamily="34" charset="-122"/>
+                <a:cs typeface="Calibri" pitchFamily="34" charset="-120"/>
+              </a:rPr>
+              <a:t>no writes to CORE/USD, no direct DB connectivity, no duplication, no access outside OB, no egress.</a:t>
+            </a:r>
+            <a:endParaRPr lang="en-US" sz="1300" dirty="0"/>
+          </a:p>
+        </p:txBody>
+      </p:sp>
+      <p:sp>
+        <p:nvSpPr>
+          <p:cNvPr id="28" name="Text 26"/>
+          <p:cNvSpPr/>
+          <p:nvPr/>
+        </p:nvSpPr>
+        <p:spPr>
+          <a:xfrm>
+            <a:off x="548640" y="5742432"/>
+            <a:ext cx="11094415" cy="320040"/>
+          </a:xfrm>
+          <a:prstGeom prst="rect">
+            <a:avLst/>
+          </a:prstGeom>
+          <a:noFill/>
+          <a:ln/>
+        </p:spPr>
+        <p:txBody>
+          <a:bodyPr wrap="square" rtlCol="0" anchor="ctr"/>
+          <a:lstStyle/>
+          <a:p>
+            <a:pPr algn="ctr" indent="0" marL="0">
+              <a:buNone/>
+            </a:pPr>
+            <a:r>
+              <a:rPr lang="en-US" sz="1150" i="1" dirty="0">
+                <a:solidFill>
+                  <a:srgbClr val="1B7F4B"/>
+                </a:solidFill>
+                <a:latin typeface="Calibri" pitchFamily="34" charset="0"/>
+                <a:ea typeface="Calibri" pitchFamily="34" charset="-122"/>
+                <a:cs typeface="Calibri" pitchFamily="34" charset="-120"/>
+              </a:rPr>
+              <a:t>Proposed and aligned to confirmed WCO Azure standards; the exact governed-data mechanism is confirmed with the Data Office before build.</a:t>
+            </a:r>
+            <a:endParaRPr lang="en-US" sz="1150" dirty="0"/>
+          </a:p>
+        </p:txBody>
+      </p:sp>
+      <p:sp>
+        <p:nvSpPr>
+          <p:cNvPr id="29" name="Text 27"/>
           <p:cNvSpPr/>
           <p:nvPr/>
         </p:nvSpPr>

</xml_diff>

<commit_message>
docs: elevate deck tone to match formalized brief; ERP/CRM naming throughout
</commit_message>
<xml_diff>
--- a/Board pitch/Owned_Brands_Board_Deck.pptx
+++ b/Board pitch/Owned_Brands_Board_Deck.pptx
@@ -1810,7 +1810,7 @@
                 <a:ea typeface="Calibri" pitchFamily="34" charset="-122"/>
                 <a:cs typeface="Calibri" pitchFamily="34" charset="-120"/>
               </a:rPr>
-              <a:t>A read-only, vendor-side intelligence and activity platform inside WCO. It surfaces the signals and tracks our engagement, so the Owned Brands team shows up at the right time with the right pitch.</a:t>
+              <a:t>A read-only, vendor-side intelligence and activity platform inside WCO. It surfaces the signals and tracks our engagement, so the Owned Brands team engages the right opportunity at the right time.</a:t>
             </a:r>
             <a:endParaRPr lang="en-US" sz="1700" dirty="0"/>
           </a:p>
@@ -2666,7 +2666,7 @@
                 <a:ea typeface="Calibri" pitchFamily="34" charset="-122"/>
                 <a:cs typeface="Calibri" pitchFamily="34" charset="-120"/>
               </a:rPr>
-              <a:t>writes to CORE/USD, direct DB connectivity, data duplication, access outside OB, or any egress.</a:t>
+              <a:t>writes to the ERP or CRM, direct DB connectivity, data duplication, access outside OB, or any egress.</a:t>
             </a:r>
             <a:endParaRPr lang="en-US" sz="1300" dirty="0"/>
           </a:p>
@@ -2705,7 +2705,7 @@
                 <a:ea typeface="Trebuchet MS" pitchFamily="34" charset="-122"/>
                 <a:cs typeface="Trebuchet MS" pitchFamily="34" charset="-120"/>
               </a:rPr>
-              <a:t>Approve these and the Owned Brands team can finally see the signals and act on them.</a:t>
+              <a:t>Approve these, and the Owned Brands team can see the signals and act on them.</a:t>
             </a:r>
             <a:endParaRPr lang="en-US" sz="1500" dirty="0"/>
           </a:p>
@@ -2776,7 +2776,7 @@
                 <a:ea typeface="Consolas" pitchFamily="34" charset="-122"/>
                 <a:cs typeface="Consolas" pitchFamily="34" charset="-120"/>
               </a:rPr>
-              <a:t>WHO WE ARE, AND WHAT’S MISSING</a:t>
+              <a:t>WHO WE ARE, AND WHAT IS MISSING</a:t>
             </a:r>
             <a:endParaRPr lang="en-US" sz="1100" dirty="0"/>
           </a:p>
@@ -2818,7 +2818,7 @@
                 <a:ea typeface="Trebuchet MS" pitchFamily="34" charset="-122"/>
                 <a:cs typeface="Trebuchet MS" pitchFamily="34" charset="-120"/>
               </a:rPr>
-              <a:t>We can’t see the signals that win deals and hold margin</a:t>
+              <a:t>We lack the signals that win deals and protect margin</a:t>
             </a:r>
             <a:endParaRPr lang="en-US" sz="2700" dirty="0"/>
           </a:p>
@@ -2943,7 +2943,7 @@
                 <a:ea typeface="Trebuchet MS" pitchFamily="34" charset="-122"/>
                 <a:cs typeface="Trebuchet MS" pitchFamily="34" charset="-120"/>
               </a:rPr>
-              <a:t>We’re the vendor team</a:t>
+              <a:t>We are the vendor team</a:t>
             </a:r>
             <a:endParaRPr lang="en-US" sz="1600" dirty="0"/>
           </a:p>
@@ -3110,7 +3110,7 @@
                 <a:ea typeface="Trebuchet MS" pitchFamily="34" charset="-122"/>
                 <a:cs typeface="Trebuchet MS" pitchFamily="34" charset="-120"/>
               </a:rPr>
-              <a:t>We fly blind</a:t>
+              <a:t>We have no early warning</a:t>
             </a:r>
             <a:endParaRPr lang="en-US" sz="1600" dirty="0"/>
           </a:p>
@@ -3152,7 +3152,7 @@
                 <a:ea typeface="Calibri" pitchFamily="34" charset="-122"/>
                 <a:cs typeface="Calibri" pitchFamily="34" charset="-120"/>
               </a:rPr>
-              <a:t>We don’t see which sellers are about to lose a winnable deal, or where competitive pressure is eroding owned-brand margin.</a:t>
+              <a:t>We cannot see which sellers are about to lose a winnable deal, or where competitive pressure is eroding owned-brand margin.</a:t>
             </a:r>
             <a:endParaRPr lang="en-US" sz="1400" dirty="0"/>
           </a:p>
@@ -3277,7 +3277,7 @@
                 <a:ea typeface="Trebuchet MS" pitchFamily="34" charset="-122"/>
                 <a:cs typeface="Trebuchet MS" pitchFamily="34" charset="-120"/>
               </a:rPr>
-              <a:t>We have no tools of our own</a:t>
+              <a:t>We have no purpose-built tools</a:t>
             </a:r>
             <a:endParaRPr lang="en-US" sz="1600" dirty="0"/>
           </a:p>
@@ -3319,7 +3319,7 @@
                 <a:ea typeface="Calibri" pitchFamily="34" charset="-122"/>
                 <a:cs typeface="Calibri" pitchFamily="34" charset="-120"/>
               </a:rPr>
-              <a:t>WCO’s systems (CORE, USD) weren’t built for the vendor lens. OB-specific tools would lift win rate and margin org-wide.</a:t>
+              <a:t>WCO’s ERP and CRM were not built for the vendor lens. Tools designed for it would lift win rate and margin organization-wide.</a:t>
             </a:r>
             <a:endParaRPr lang="en-US" sz="1400" dirty="0"/>
           </a:p>
@@ -3358,7 +3358,7 @@
                 <a:ea typeface="Calibri" pitchFamily="34" charset="-122"/>
                 <a:cs typeface="Calibri" pitchFamily="34" charset="-120"/>
               </a:rPr>
-              <a:t>The platform’s job: surface those signals and put us in the right place at the right time.</a:t>
+              <a:t>The platform’s role: surface those signals and position the Owned Brands team where it can change the outcome.</a:t>
             </a:r>
             <a:endParaRPr lang="en-US" sz="1500" dirty="0"/>
           </a:p>
@@ -3524,7 +3524,7 @@
                 <a:ea typeface="Trebuchet MS" pitchFamily="34" charset="-122"/>
                 <a:cs typeface="Trebuchet MS" pitchFamily="34" charset="-120"/>
               </a:rPr>
-              <a:t>A deal we’d lose today, and how we win it</a:t>
+              <a:t>A deal we would lose today, and how the platform wins it</a:t>
             </a:r>
             <a:endParaRPr lang="en-US" sz="2700" dirty="0"/>
           </a:p>
@@ -3965,7 +3965,7 @@
                 <a:ea typeface="Calibri" pitchFamily="34" charset="-122"/>
                 <a:cs typeface="Calibri" pitchFamily="34" charset="-120"/>
               </a:rPr>
-              <a:t>Today no system surfaces this seller in time. That is the gap, and the whole point of the platform.</a:t>
+              <a:t>Today no system surfaces this seller in time. Closing that gap is the platform’s core purpose.</a:t>
             </a:r>
             <a:endParaRPr lang="en-US" sz="1500" dirty="0"/>
           </a:p>
@@ -4131,7 +4131,7 @@
                 <a:ea typeface="Trebuchet MS" pitchFamily="34" charset="-122"/>
                 <a:cs typeface="Trebuchet MS" pitchFamily="34" charset="-120"/>
               </a:rPr>
-              <a:t>One loop puts us in the right deal at the right time</a:t>
+              <a:t>One loop moves a signal to a closed, higher-margin deal</a:t>
             </a:r>
             <a:endParaRPr lang="en-US" sz="2700" dirty="0"/>
           </a:p>
@@ -4298,7 +4298,7 @@
                 <a:ea typeface="Calibri" pitchFamily="34" charset="-122"/>
                 <a:cs typeface="Calibri" pitchFamily="34" charset="-120"/>
               </a:rPr>
-              <a:t>Signal in the governed data: a deal at risk or margin under pressure</a:t>
+              <a:t>A signal in the governed data: a deal at risk or margin under pressure</a:t>
             </a:r>
             <a:endParaRPr lang="en-US" sz="1300" dirty="0"/>
           </a:p>
@@ -4710,7 +4710,7 @@
                 <a:ea typeface="Calibri" pitchFamily="34" charset="-122"/>
                 <a:cs typeface="Calibri" pitchFamily="34" charset="-120"/>
               </a:rPr>
-              <a:t>Help close the deal and hold owned-brand margin</a:t>
+              <a:t>Help close the deal and protect owned-brand margin</a:t>
             </a:r>
             <a:endParaRPr lang="en-US" sz="1300" dirty="0"/>
           </a:p>
@@ -4916,7 +4916,7 @@
                 <a:ea typeface="Calibri" pitchFamily="34" charset="-122"/>
                 <a:cs typeface="Calibri" pitchFamily="34" charset="-120"/>
               </a:rPr>
-              <a:t>Owned brands grow; the engagement is tracked</a:t>
+              <a:t>Owned-brand share grows; the engagement is captured</a:t>
             </a:r>
             <a:endParaRPr lang="en-US" sz="1300" dirty="0"/>
           </a:p>
@@ -5475,7 +5475,7 @@
                 <a:ea typeface="Calibri" pitchFamily="34" charset="-122"/>
                 <a:cs typeface="Calibri" pitchFamily="34" charset="-120"/>
               </a:rPr>
-              <a:t>Where to show up: deals at risk, margin under pressure, stock signal.</a:t>
+              <a:t>Where to engage: deals at risk, margin under pressure, and the supporting stock signal.</a:t>
             </a:r>
             <a:endParaRPr lang="en-US" sz="1250" dirty="0"/>
           </a:p>
@@ -5642,7 +5642,7 @@
                 <a:ea typeface="Calibri" pitchFamily="34" charset="-122"/>
                 <a:cs typeface="Calibri" pitchFamily="34" charset="-120"/>
               </a:rPr>
-              <a:t>OB-generated opportunities; engagement with WCO sellers, our customer (not in USD).</a:t>
+              <a:t>OB-generated opportunities; engagement with WCO sellers, our customer (not in the CRM).</a:t>
             </a:r>
             <a:endParaRPr lang="en-US" sz="1250" dirty="0"/>
           </a:p>
@@ -5809,7 +5809,7 @@
                 <a:ea typeface="Calibri" pitchFamily="34" charset="-122"/>
                 <a:cs typeface="Calibri" pitchFamily="34" charset="-120"/>
               </a:rPr>
-              <a:t>A note to records; opportunity-loss and product-development signals.</a:t>
+              <a:t>A note becomes structured records; opportunity-loss and product signals.</a:t>
             </a:r>
             <a:endParaRPr lang="en-US" sz="1250" dirty="0"/>
           </a:p>
@@ -6348,7 +6348,7 @@
                 <a:ea typeface="Trebuchet MS" pitchFamily="34" charset="-122"/>
                 <a:cs typeface="Trebuchet MS" pitchFamily="34" charset="-120"/>
               </a:rPr>
-              <a:t>Already built: the leadership view</a:t>
+              <a:t>Already prototyped: the leadership view</a:t>
             </a:r>
             <a:endParaRPr lang="en-US" sz="2700" dirty="0"/>
           </a:p>
@@ -7066,7 +7066,7 @@
                 <a:ea typeface="Calibri" pitchFamily="34" charset="-122"/>
                 <a:cs typeface="Calibri" pitchFamily="34" charset="-120"/>
               </a:rPr>
-              <a:t>We just integrated the LCO sales organization</a:t>
+              <a:t>We have integrated the LCO sales organization</a:t>
             </a:r>
             <a:pPr indent="0" marL="0">
               <a:lnSpc>
@@ -7083,7 +7083,7 @@
                 <a:ea typeface="Calibri" pitchFamily="34" charset="-122"/>
                 <a:cs typeface="Calibri" pitchFamily="34" charset="-120"/>
               </a:rPr>
-              <a:t>, adding capability and aligning structure to the Owned Brands mandate inside WCO. The structure is in place; the missing piece is the toolset that lets it see around corners that are blind today.</a:t>
+              <a:t>, adding capability and aligning structure to the Owned Brands mandate inside WCO. The structure is in place; the missing piece is the toolset that gives it the visibility it does not have today.</a:t>
             </a:r>
             <a:endParaRPr lang="en-US" sz="1700" dirty="0"/>
           </a:p>
@@ -7125,7 +7125,7 @@
                 <a:ea typeface="Calibri" pitchFamily="34" charset="-122"/>
                 <a:cs typeface="Calibri" pitchFamily="34" charset="-120"/>
               </a:rPr>
-              <a:t>Equip the team now and that structural investment compounds. Wait, and winnable deals like the one we just walked through keep slipping, quietly.</a:t>
+              <a:t>Equipping the team now compounds that structural investment. Without it, winnable deals like the one above continue to slip away unseen.</a:t>
             </a:r>
             <a:endParaRPr lang="en-US" sz="1700" dirty="0"/>
           </a:p>
@@ -7433,7 +7433,7 @@
                 <a:ea typeface="Trebuchet MS" pitchFamily="34" charset="-122"/>
                 <a:cs typeface="Trebuchet MS" pitchFamily="34" charset="-120"/>
               </a:rPr>
-              <a:t>Read-only in, governed all the way through, the win out</a:t>
+              <a:t>Governed end to end: read-only data in, the win out</a:t>
             </a:r>
             <a:endParaRPr lang="en-US" sz="2700" dirty="0"/>
           </a:p>
@@ -7541,7 +7541,7 @@
                 <a:ea typeface="Calibri" pitchFamily="34" charset="-122"/>
                 <a:cs typeface="Calibri" pitchFamily="34" charset="-120"/>
               </a:rPr>
-              <a:t>CORE (ERP)</a:t>
+              <a:t>ERP (CORE)</a:t>
             </a:r>
             <a:endParaRPr lang="en-US" sz="1200" dirty="0"/>
           </a:p>
@@ -7561,7 +7561,7 @@
                 <a:ea typeface="Calibri" pitchFamily="34" charset="-122"/>
                 <a:cs typeface="Calibri" pitchFamily="34" charset="-120"/>
               </a:rPr>
-              <a:t>USD (CRM)</a:t>
+              <a:t>CRM (USD)</a:t>
             </a:r>
             <a:endParaRPr lang="en-US" sz="1200" dirty="0"/>
           </a:p>
@@ -8439,7 +8439,7 @@
                 <a:ea typeface="Calibri" pitchFamily="34" charset="-122"/>
                 <a:cs typeface="Calibri" pitchFamily="34" charset="-120"/>
               </a:rPr>
-              <a:t>no writes to CORE/USD, no direct DB connectivity, no duplication, no access outside OB, no egress.</a:t>
+              <a:t>no writes to the ERP or CRM, no direct DB connectivity, no duplication, no access outside OB, no egress.</a:t>
             </a:r>
             <a:endParaRPr lang="en-US" sz="1300" dirty="0"/>
           </a:p>

</xml_diff>

<commit_message>
docs(deck): merge slide edits; flip slide 2 to upside; growth-cycle replaces 90-day KPI; wireframe (not prototype) language
</commit_message>
<xml_diff>
--- a/Board pitch/Owned_Brands_Board_Deck.pptx
+++ b/Board pitch/Owned_Brands_Board_Deck.pptx
@@ -1751,7 +1751,7 @@
                 <a:ea typeface="Trebuchet MS" pitchFamily="34" charset="-122"/>
                 <a:cs typeface="Trebuchet MS" pitchFamily="34" charset="-120"/>
               </a:rPr>
-              <a:t>The signals to help WCO sellers win deals</a:t>
+              <a:t>Uncover the signals to help WCO sellers win deals</a:t>
             </a:r>
             <a:endParaRPr lang="en-US" sz="4000" dirty="0"/>
           </a:p>
@@ -1771,7 +1771,7 @@
                 <a:ea typeface="Trebuchet MS" pitchFamily="34" charset="-122"/>
                 <a:cs typeface="Trebuchet MS" pitchFamily="34" charset="-120"/>
               </a:rPr>
-              <a:t>and hold owned-brand margin.</a:t>
+              <a:t>and increase owned-brand margin.</a:t>
             </a:r>
             <a:endParaRPr lang="en-US" sz="4000" dirty="0"/>
           </a:p>
@@ -1810,7 +1810,7 @@
                 <a:ea typeface="Calibri" pitchFamily="34" charset="-122"/>
                 <a:cs typeface="Calibri" pitchFamily="34" charset="-120"/>
               </a:rPr>
-              <a:t>A read-only, vendor-side intelligence and activity platform inside WCO. It surfaces the signals and tracks our engagement, so the Owned Brands team engages the right opportunity at the right time.</a:t>
+              <a:t>A read-only, vendor-side intelligence and activity platform inside WCO, fit to Owned Brands’ mandate. It surfaces the signals and tracks our engagement, so the Owned Brands team engages the right opportunity at the right time.</a:t>
             </a:r>
             <a:endParaRPr lang="en-US" sz="1700" dirty="0"/>
           </a:p>
@@ -1999,7 +1999,7 @@
                 <a:ea typeface="Calibri" pitchFamily="34" charset="-122"/>
                 <a:cs typeface="Calibri" pitchFamily="34" charset="-120"/>
               </a:rPr>
-              <a:t>Jeff Goodman   ·   Director, Sales, Owned Brands   ·   June 19, 2026   ·   Status: Discovery / prototype</a:t>
+              <a:t>Jeff Goodman   ·   Director, Sales, Owned Brands   ·   June 19, 2026   ·   Status: Discovery / wireframe</a:t>
             </a:r>
             <a:endParaRPr lang="en-US" sz="1100" dirty="0"/>
           </a:p>
@@ -2776,7 +2776,7 @@
                 <a:ea typeface="Consolas" pitchFamily="34" charset="-122"/>
                 <a:cs typeface="Consolas" pitchFamily="34" charset="-120"/>
               </a:rPr>
-              <a:t>WHO WE ARE, AND WHAT IS MISSING</a:t>
+              <a:t>WHO WE ARE, AND WHAT DATA UNLOCKS</a:t>
             </a:r>
             <a:endParaRPr lang="en-US" sz="1100" dirty="0"/>
           </a:p>
@@ -2818,7 +2818,7 @@
                 <a:ea typeface="Trebuchet MS" pitchFamily="34" charset="-122"/>
                 <a:cs typeface="Trebuchet MS" pitchFamily="34" charset="-120"/>
               </a:rPr>
-              <a:t>We lack the signals that win deals and protect margin</a:t>
+              <a:t>Insights surfaced at the right time increase margin company-wide</a:t>
             </a:r>
             <a:endParaRPr lang="en-US" sz="2700" dirty="0"/>
           </a:p>
@@ -2918,17 +2918,17 @@
         </p:nvSpPr>
         <p:spPr>
           <a:xfrm>
-            <a:off x="822960" y="3154680"/>
-            <a:ext cx="2966618" cy="640080"/>
-          </a:xfrm>
-          <a:prstGeom prst="rect">
-            <a:avLst/>
-          </a:prstGeom>
-          <a:noFill/>
-          <a:ln/>
-        </p:spPr>
-        <p:txBody>
-          <a:bodyPr wrap="square" rtlCol="0" anchor="ctr"/>
+            <a:off x="822960" y="3063240"/>
+            <a:ext cx="2966618" cy="713232"/>
+          </a:xfrm>
+          <a:prstGeom prst="rect">
+            <a:avLst/>
+          </a:prstGeom>
+          <a:noFill/>
+          <a:ln/>
+        </p:spPr>
+        <p:txBody>
+          <a:bodyPr wrap="square" rtlCol="0" anchor="b"/>
           <a:lstStyle/>
           <a:p>
             <a:pPr indent="0" marL="0">
@@ -2943,7 +2943,7 @@
                 <a:ea typeface="Trebuchet MS" pitchFamily="34" charset="-122"/>
                 <a:cs typeface="Trebuchet MS" pitchFamily="34" charset="-120"/>
               </a:rPr>
-              <a:t>We are the vendor team</a:t>
+              <a:t>We are the Owned Brands vendor team</a:t>
             </a:r>
             <a:endParaRPr lang="en-US" sz="1600" dirty="0"/>
           </a:p>
@@ -2957,7 +2957,7 @@
         </p:nvSpPr>
         <p:spPr>
           <a:xfrm>
-            <a:off x="822960" y="3840480"/>
+            <a:off x="822960" y="3886200"/>
             <a:ext cx="2966618" cy="1280160"/>
           </a:xfrm>
           <a:prstGeom prst="rect">
@@ -2985,7 +2985,7 @@
                 <a:ea typeface="Calibri" pitchFamily="34" charset="-122"/>
                 <a:cs typeface="Calibri" pitchFamily="34" charset="-120"/>
               </a:rPr>
-              <a:t>WCO is our primary customer. The Owned Brands team calls on WCO sellers and select customers to help them win with owned brands.</a:t>
+              <a:t>WCO is our primary customer. We call on WCO sellers and select customers to help them win with owned brands.</a:t>
             </a:r>
             <a:endParaRPr lang="en-US" sz="1400" dirty="0"/>
           </a:p>
@@ -3071,7 +3071,7 @@
                 <a:ea typeface="Consolas" pitchFamily="34" charset="-122"/>
                 <a:cs typeface="Consolas" pitchFamily="34" charset="-120"/>
               </a:rPr>
-              <a:t>⚑</a:t>
+              <a:t>◎</a:t>
             </a:r>
             <a:endParaRPr lang="en-US" sz="1800" dirty="0"/>
           </a:p>
@@ -3085,17 +3085,17 @@
         </p:nvSpPr>
         <p:spPr>
           <a:xfrm>
-            <a:off x="4612538" y="3154680"/>
-            <a:ext cx="2966618" cy="640080"/>
-          </a:xfrm>
-          <a:prstGeom prst="rect">
-            <a:avLst/>
-          </a:prstGeom>
-          <a:noFill/>
-          <a:ln/>
-        </p:spPr>
-        <p:txBody>
-          <a:bodyPr wrap="square" rtlCol="0" anchor="ctr"/>
+            <a:off x="4612538" y="3063240"/>
+            <a:ext cx="2966618" cy="713232"/>
+          </a:xfrm>
+          <a:prstGeom prst="rect">
+            <a:avLst/>
+          </a:prstGeom>
+          <a:noFill/>
+          <a:ln/>
+        </p:spPr>
+        <p:txBody>
+          <a:bodyPr wrap="square" rtlCol="0" anchor="b"/>
           <a:lstStyle/>
           <a:p>
             <a:pPr indent="0" marL="0">
@@ -3110,7 +3110,7 @@
                 <a:ea typeface="Trebuchet MS" pitchFamily="34" charset="-122"/>
                 <a:cs typeface="Trebuchet MS" pitchFamily="34" charset="-120"/>
               </a:rPr>
-              <a:t>We have no early warning</a:t>
+              <a:t>Insight compounds our edge</a:t>
             </a:r>
             <a:endParaRPr lang="en-US" sz="1600" dirty="0"/>
           </a:p>
@@ -3124,7 +3124,7 @@
         </p:nvSpPr>
         <p:spPr>
           <a:xfrm>
-            <a:off x="4612538" y="3840480"/>
+            <a:off x="4612538" y="3886200"/>
             <a:ext cx="2966618" cy="1280160"/>
           </a:xfrm>
           <a:prstGeom prst="rect">
@@ -3152,7 +3152,7 @@
                 <a:ea typeface="Calibri" pitchFamily="34" charset="-122"/>
                 <a:cs typeface="Calibri" pitchFamily="34" charset="-120"/>
               </a:rPr>
-              <a:t>We cannot see which sellers are about to lose a winnable deal, or where competitive pressure is eroding owned-brand margin.</a:t>
+              <a:t>We help WCO sellers compete and win with higher margins. More data sharpens that, spotting competitive pressure early and protecting margin.</a:t>
             </a:r>
             <a:endParaRPr lang="en-US" sz="1400" dirty="0"/>
           </a:p>
@@ -3252,17 +3252,17 @@
         </p:nvSpPr>
         <p:spPr>
           <a:xfrm>
-            <a:off x="8402117" y="3154680"/>
-            <a:ext cx="2966618" cy="640080"/>
-          </a:xfrm>
-          <a:prstGeom prst="rect">
-            <a:avLst/>
-          </a:prstGeom>
-          <a:noFill/>
-          <a:ln/>
-        </p:spPr>
-        <p:txBody>
-          <a:bodyPr wrap="square" rtlCol="0" anchor="ctr"/>
+            <a:off x="8402117" y="3063240"/>
+            <a:ext cx="2966618" cy="713232"/>
+          </a:xfrm>
+          <a:prstGeom prst="rect">
+            <a:avLst/>
+          </a:prstGeom>
+          <a:noFill/>
+          <a:ln/>
+        </p:spPr>
+        <p:txBody>
+          <a:bodyPr wrap="square" rtlCol="0" anchor="b"/>
           <a:lstStyle/>
           <a:p>
             <a:pPr indent="0" marL="0">
@@ -3277,7 +3277,7 @@
                 <a:ea typeface="Trebuchet MS" pitchFamily="34" charset="-122"/>
                 <a:cs typeface="Trebuchet MS" pitchFamily="34" charset="-120"/>
               </a:rPr>
-              <a:t>We have no purpose-built tools</a:t>
+              <a:t>A tool built for the vendor lens</a:t>
             </a:r>
             <a:endParaRPr lang="en-US" sz="1600" dirty="0"/>
           </a:p>
@@ -3291,7 +3291,7 @@
         </p:nvSpPr>
         <p:spPr>
           <a:xfrm>
-            <a:off x="8402117" y="3840480"/>
+            <a:off x="8402117" y="3886200"/>
             <a:ext cx="2966618" cy="1280160"/>
           </a:xfrm>
           <a:prstGeom prst="rect">
@@ -3319,7 +3319,7 @@
                 <a:ea typeface="Calibri" pitchFamily="34" charset="-122"/>
                 <a:cs typeface="Calibri" pitchFamily="34" charset="-120"/>
               </a:rPr>
-              <a:t>WCO’s ERP and CRM were not built for the vendor lens. Tools designed for it would lift win rate and margin organization-wide.</a:t>
+              <a:t>What WCO’s ERP and CRM cannot do for a vendor, this tool does, lifting win rate and margin organization-wide.</a:t>
             </a:r>
             <a:endParaRPr lang="en-US" sz="1400" dirty="0"/>
           </a:p>
@@ -3632,7 +3632,7 @@
                 <a:ea typeface="Calibri" pitchFamily="34" charset="-122"/>
                 <a:cs typeface="Calibri" pitchFamily="34" charset="-120"/>
               </a:rPr>
-              <a:t>A WCO seller is bidding a security project: a national-brand camera line, with the rest of the bill of materials still open. The seller sourced it and holds registered project pricing on the cameras.</a:t>
+              <a:t>A WCO seller specified a security project around a national-brand camera line and secured registered project pricing. The rest of the bill of materials is still open.</a:t>
             </a:r>
             <a:endParaRPr lang="en-US" sz="1450" dirty="0"/>
           </a:p>
@@ -3779,7 +3779,7 @@
                 <a:ea typeface="Calibri" pitchFamily="34" charset="-122"/>
                 <a:cs typeface="Calibri" pitchFamily="34" charset="-120"/>
               </a:rPr>
-              <a:t>A competing distributor bids the same cameras, but pairs them with its own-brand cable. The extra margin on that cable lets it beat our total price, registered pricing and all.</a:t>
+              <a:t>A competing distributor bids the same cameras, but pairs them with its own-brand cable, power supplies, and racking. The extra margin on that hardware lets it beat our total price, despite our registered pricing.</a:t>
             </a:r>
             <a:endParaRPr lang="en-US" sz="1450" dirty="0"/>
           </a:p>
@@ -5141,7 +5141,7 @@
                 <a:ea typeface="Trebuchet MS" pitchFamily="34" charset="-122"/>
                 <a:cs typeface="Trebuchet MS" pitchFamily="34" charset="-120"/>
               </a:rPr>
-              <a:t>A vendor-side platform and CRM, already prototyped</a:t>
+              <a:t>A vendor-side platform and CRM, designed end to end</a:t>
             </a:r>
             <a:endParaRPr lang="en-US" sz="2700" dirty="0"/>
           </a:p>
@@ -5642,7 +5642,7 @@
                 <a:ea typeface="Calibri" pitchFamily="34" charset="-122"/>
                 <a:cs typeface="Calibri" pitchFamily="34" charset="-120"/>
               </a:rPr>
-              <a:t>OB-generated opportunities; engagement with WCO sellers, our customer (not in the CRM).</a:t>
+              <a:t>OB-generated opportunities and engagement with WCO sellers; intercompany activity the CRM cannot track.</a:t>
             </a:r>
             <a:endParaRPr lang="en-US" sz="1250" dirty="0"/>
           </a:p>
@@ -6182,7 +6182,7 @@
                 <a:ea typeface="Calibri" pitchFamily="34" charset="-122"/>
                 <a:cs typeface="Calibri" pitchFamily="34" charset="-120"/>
               </a:rPr>
-              <a:t>Built read-only and in-tenant. Margin/cost confined to the authorized OB group.</a:t>
+              <a:t>By design, read-only and in-tenant; margin/cost confined to the authorized OB group.</a:t>
             </a:r>
             <a:endParaRPr lang="en-US" sz="1400" dirty="0"/>
           </a:p>
@@ -6306,7 +6306,7 @@
                 <a:ea typeface="Consolas" pitchFamily="34" charset="-122"/>
                 <a:cs typeface="Consolas" pitchFamily="34" charset="-120"/>
               </a:rPr>
-              <a:t>PROOF</a:t>
+              <a:t>THE DESIGN</a:t>
             </a:r>
             <a:endParaRPr lang="en-US" sz="1100" dirty="0"/>
           </a:p>
@@ -6348,7 +6348,7 @@
                 <a:ea typeface="Trebuchet MS" pitchFamily="34" charset="-122"/>
                 <a:cs typeface="Trebuchet MS" pitchFamily="34" charset="-120"/>
               </a:rPr>
-              <a:t>Already prototyped: the leadership view</a:t>
+              <a:t>The leadership view, wireframed</a:t>
             </a:r>
             <a:endParaRPr lang="en-US" sz="2700" dirty="0"/>
           </a:p>
@@ -6858,7 +6858,7 @@
                 <a:ea typeface="Calibri" pitchFamily="34" charset="-122"/>
                 <a:cs typeface="Calibri" pitchFamily="34" charset="-120"/>
               </a:rPr>
-              <a:t>Working two-persona wireframe (Leadership + Sales Team); sample data only. This is proven UX, not a concept.</a:t>
+              <a:t>A wireframe of the two-persona design (Leadership + Sales Team) on sample data. It shows the intended experience, not a built product.</a:t>
             </a:r>
             <a:endParaRPr lang="en-US" sz="1300" dirty="0"/>
           </a:p>
@@ -7024,7 +7024,7 @@
                 <a:ea typeface="Trebuchet MS" pitchFamily="34" charset="-122"/>
                 <a:cs typeface="Trebuchet MS" pitchFamily="34" charset="-120"/>
               </a:rPr>
-              <a:t>The team is built to execute. The tool is the missing piece.</a:t>
+              <a:t>The team is built to execute; this tool is the growth engine</a:t>
             </a:r>
             <a:endParaRPr lang="en-US" sz="2700" dirty="0"/>
           </a:p>
@@ -7083,7 +7083,7 @@
                 <a:ea typeface="Calibri" pitchFamily="34" charset="-122"/>
                 <a:cs typeface="Calibri" pitchFamily="34" charset="-120"/>
               </a:rPr>
-              <a:t>, adding capability and aligning structure to the Owned Brands mandate inside WCO. The structure is in place; the missing piece is the toolset that gives it the visibility it does not have today.</a:t>
+              <a:t>, adding capability and aligning structure to the Owned Brands mandate inside WCO. The structure is in place and delivering today.</a:t>
             </a:r>
             <a:endParaRPr lang="en-US" sz="1700" dirty="0"/>
           </a:p>
@@ -7097,7 +7097,7 @@
         </p:nvSpPr>
         <p:spPr>
           <a:xfrm>
-            <a:off x="548640" y="3611880"/>
+            <a:off x="548640" y="3520440"/>
             <a:ext cx="6400800" cy="1280160"/>
           </a:xfrm>
           <a:prstGeom prst="rect">
@@ -7125,7 +7125,7 @@
                 <a:ea typeface="Calibri" pitchFamily="34" charset="-122"/>
                 <a:cs typeface="Calibri" pitchFamily="34" charset="-120"/>
               </a:rPr>
-              <a:t>Equipping the team now compounds that structural investment. Without it, winnable deals like the one above continue to slip away unseen.</a:t>
+              <a:t>This tool turns what we are learning into a repeatable growth cycle, compounding that structural investment quarter over quarter.</a:t>
             </a:r>
             <a:endParaRPr lang="en-US" sz="1700" dirty="0"/>
           </a:p>
@@ -7161,7 +7161,7 @@
         </p:nvSpPr>
         <p:spPr>
           <a:xfrm>
-            <a:off x="7498080" y="2514600"/>
+            <a:off x="7498080" y="2487168"/>
             <a:ext cx="4144975" cy="320040"/>
           </a:xfrm>
           <a:prstGeom prst="rect">
@@ -7186,7 +7186,7 @@
                 <a:ea typeface="Consolas" pitchFamily="34" charset="-122"/>
                 <a:cs typeface="Consolas" pitchFamily="34" charset="-120"/>
               </a:rPr>
-              <a:t>FIRST 90 DAYS</a:t>
+              <a:t>THE GROWTH CYCLE</a:t>
             </a:r>
             <a:endParaRPr lang="en-US" sz="1200" dirty="0"/>
           </a:p>
@@ -7200,8 +7200,8 @@
         </p:nvSpPr>
         <p:spPr>
           <a:xfrm>
-            <a:off x="7498080" y="2743200"/>
-            <a:ext cx="4144975" cy="1463040"/>
+            <a:off x="7772400" y="2944368"/>
+            <a:ext cx="3596335" cy="365760"/>
           </a:xfrm>
           <a:prstGeom prst="rect">
             <a:avLst/>
@@ -7217,7 +7217,7 @@
               <a:buNone/>
             </a:pPr>
             <a:r>
-              <a:rPr lang="en-US" sz="9600" b="1" dirty="0">
+              <a:rPr lang="en-US" sz="1700" b="1" dirty="0">
                 <a:solidFill>
                   <a:srgbClr val="FFFFFF"/>
                 </a:solidFill>
@@ -7225,9 +7225,9 @@
                 <a:ea typeface="Trebuchet MS" pitchFamily="34" charset="-122"/>
                 <a:cs typeface="Trebuchet MS" pitchFamily="34" charset="-120"/>
               </a:rPr>
-              <a:t>30</a:t>
-            </a:r>
-            <a:endParaRPr lang="en-US" sz="9600" dirty="0"/>
+              <a:t>Win the deal</a:t>
+            </a:r>
+            <a:endParaRPr lang="en-US" sz="1700" dirty="0"/>
           </a:p>
         </p:txBody>
       </p:sp>
@@ -7239,8 +7239,8 @@
         </p:nvSpPr>
         <p:spPr>
           <a:xfrm>
-            <a:off x="7863840" y="4297680"/>
-            <a:ext cx="3413455" cy="822960"/>
+            <a:off x="7498080" y="3273552"/>
+            <a:ext cx="4144975" cy="237744"/>
           </a:xfrm>
           <a:prstGeom prst="rect">
             <a:avLst/>
@@ -7253,13 +7253,166 @@
           <a:lstStyle/>
           <a:p>
             <a:pPr algn="ctr" indent="0" marL="0">
-              <a:lnSpc>
-                <a:spcPct val="105000"/>
-              </a:lnSpc>
-              <a:buNone/>
-            </a:pPr>
-            <a:r>
-              <a:rPr lang="en-US" sz="1500" dirty="0">
+              <a:buNone/>
+            </a:pPr>
+            <a:r>
+              <a:rPr lang="en-US" sz="1300" dirty="0">
+                <a:solidFill>
+                  <a:srgbClr val="37B26B"/>
+                </a:solidFill>
+                <a:latin typeface="Consolas" pitchFamily="34" charset="0"/>
+                <a:ea typeface="Consolas" pitchFamily="34" charset="-122"/>
+                <a:cs typeface="Consolas" pitchFamily="34" charset="-120"/>
+              </a:rPr>
+              <a:t>↓</a:t>
+            </a:r>
+            <a:endParaRPr lang="en-US" sz="1300" dirty="0"/>
+          </a:p>
+        </p:txBody>
+      </p:sp>
+      <p:sp>
+        <p:nvSpPr>
+          <p:cNvPr id="10" name="Text 8"/>
+          <p:cNvSpPr/>
+          <p:nvPr/>
+        </p:nvSpPr>
+        <p:spPr>
+          <a:xfrm>
+            <a:off x="7772400" y="3547872"/>
+            <a:ext cx="3596335" cy="365760"/>
+          </a:xfrm>
+          <a:prstGeom prst="rect">
+            <a:avLst/>
+          </a:prstGeom>
+          <a:noFill/>
+          <a:ln/>
+        </p:spPr>
+        <p:txBody>
+          <a:bodyPr wrap="square" rtlCol="0" anchor="ctr"/>
+          <a:lstStyle/>
+          <a:p>
+            <a:pPr algn="ctr" indent="0" marL="0">
+              <a:buNone/>
+            </a:pPr>
+            <a:r>
+              <a:rPr lang="en-US" sz="1700" b="1" dirty="0">
+                <a:solidFill>
+                  <a:srgbClr val="FFFFFF"/>
+                </a:solidFill>
+                <a:latin typeface="Trebuchet MS" pitchFamily="34" charset="0"/>
+                <a:ea typeface="Trebuchet MS" pitchFamily="34" charset="-122"/>
+                <a:cs typeface="Trebuchet MS" pitchFamily="34" charset="-120"/>
+              </a:rPr>
+              <a:t>Capture the lesson</a:t>
+            </a:r>
+            <a:endParaRPr lang="en-US" sz="1700" dirty="0"/>
+          </a:p>
+        </p:txBody>
+      </p:sp>
+      <p:sp>
+        <p:nvSpPr>
+          <p:cNvPr id="11" name="Text 9"/>
+          <p:cNvSpPr/>
+          <p:nvPr/>
+        </p:nvSpPr>
+        <p:spPr>
+          <a:xfrm>
+            <a:off x="7498080" y="3877056"/>
+            <a:ext cx="4144975" cy="237744"/>
+          </a:xfrm>
+          <a:prstGeom prst="rect">
+            <a:avLst/>
+          </a:prstGeom>
+          <a:noFill/>
+          <a:ln/>
+        </p:spPr>
+        <p:txBody>
+          <a:bodyPr wrap="square" rtlCol="0" anchor="ctr"/>
+          <a:lstStyle/>
+          <a:p>
+            <a:pPr algn="ctr" indent="0" marL="0">
+              <a:buNone/>
+            </a:pPr>
+            <a:r>
+              <a:rPr lang="en-US" sz="1300" dirty="0">
+                <a:solidFill>
+                  <a:srgbClr val="37B26B"/>
+                </a:solidFill>
+                <a:latin typeface="Consolas" pitchFamily="34" charset="0"/>
+                <a:ea typeface="Consolas" pitchFamily="34" charset="-122"/>
+                <a:cs typeface="Consolas" pitchFamily="34" charset="-120"/>
+              </a:rPr>
+              <a:t>↓</a:t>
+            </a:r>
+            <a:endParaRPr lang="en-US" sz="1300" dirty="0"/>
+          </a:p>
+        </p:txBody>
+      </p:sp>
+      <p:sp>
+        <p:nvSpPr>
+          <p:cNvPr id="12" name="Text 10"/>
+          <p:cNvSpPr/>
+          <p:nvPr/>
+        </p:nvSpPr>
+        <p:spPr>
+          <a:xfrm>
+            <a:off x="7772400" y="4151376"/>
+            <a:ext cx="3596335" cy="365760"/>
+          </a:xfrm>
+          <a:prstGeom prst="rect">
+            <a:avLst/>
+          </a:prstGeom>
+          <a:noFill/>
+          <a:ln/>
+        </p:spPr>
+        <p:txBody>
+          <a:bodyPr wrap="square" rtlCol="0" anchor="ctr"/>
+          <a:lstStyle/>
+          <a:p>
+            <a:pPr algn="ctr" indent="0" marL="0">
+              <a:buNone/>
+            </a:pPr>
+            <a:r>
+              <a:rPr lang="en-US" sz="1700" b="1" dirty="0">
+                <a:solidFill>
+                  <a:srgbClr val="FFFFFF"/>
+                </a:solidFill>
+                <a:latin typeface="Trebuchet MS" pitchFamily="34" charset="0"/>
+                <a:ea typeface="Trebuchet MS" pitchFamily="34" charset="-122"/>
+                <a:cs typeface="Trebuchet MS" pitchFamily="34" charset="-120"/>
+              </a:rPr>
+              <a:t>Sharpen the next play</a:t>
+            </a:r>
+            <a:endParaRPr lang="en-US" sz="1700" dirty="0"/>
+          </a:p>
+        </p:txBody>
+      </p:sp>
+      <p:sp>
+        <p:nvSpPr>
+          <p:cNvPr id="13" name="Text 11"/>
+          <p:cNvSpPr/>
+          <p:nvPr/>
+        </p:nvSpPr>
+        <p:spPr>
+          <a:xfrm>
+            <a:off x="7772400" y="4754880"/>
+            <a:ext cx="3596335" cy="365760"/>
+          </a:xfrm>
+          <a:prstGeom prst="rect">
+            <a:avLst/>
+          </a:prstGeom>
+          <a:noFill/>
+          <a:ln/>
+        </p:spPr>
+        <p:txBody>
+          <a:bodyPr wrap="square" rtlCol="0" anchor="ctr"/>
+          <a:lstStyle/>
+          <a:p>
+            <a:pPr algn="ctr" indent="0" marL="0">
+              <a:buNone/>
+            </a:pPr>
+            <a:r>
+              <a:rPr lang="en-US" sz="1300" i="1" dirty="0">
                 <a:solidFill>
                   <a:srgbClr val="D6E8DD"/>
                 </a:solidFill>
@@ -7267,15 +7420,15 @@
                 <a:ea typeface="Calibri" pitchFamily="34" charset="-122"/>
                 <a:cs typeface="Calibri" pitchFamily="34" charset="-120"/>
               </a:rPr>
-              <a:t>opportunities WCO would otherwise have lost, identified and supported.</a:t>
-            </a:r>
-            <a:endParaRPr lang="en-US" sz="1500" dirty="0"/>
-          </a:p>
-        </p:txBody>
-      </p:sp>
-      <p:sp>
-        <p:nvSpPr>
-          <p:cNvPr id="10" name="Text 8"/>
+              <a:t>Repeats, compounding every quarter.</a:t>
+            </a:r>
+            <a:endParaRPr lang="en-US" sz="1300" dirty="0"/>
+          </a:p>
+        </p:txBody>
+      </p:sp>
+      <p:sp>
+        <p:nvSpPr>
+          <p:cNvPr id="14" name="Text 12"/>
           <p:cNvSpPr/>
           <p:nvPr/>
         </p:nvSpPr>
@@ -8807,7 +8960,7 @@
                 <a:ea typeface="Calibri" pitchFamily="34" charset="-122"/>
                 <a:cs typeface="Calibri" pitchFamily="34" charset="-120"/>
               </a:rPr>
-              <a:t>Scoping, prototype, access one-pager, systems discovery</a:t>
+              <a:t>Scoping, wireframe, access one-pager, systems discovery</a:t>
             </a:r>
             <a:endParaRPr lang="en-US" sz="1250" dirty="0"/>
           </a:p>

</xml_diff>